<commit_message>
apres la modifictaion du diapo final
</commit_message>
<xml_diff>
--- a/osis_Ibrahim_S3conclusion_finale.pptx
+++ b/osis_Ibrahim_S3conclusion_finale.pptx
@@ -982,7 +982,7 @@
           <a:p>
             <a:r>
               <a:rPr lang="en-US" dirty="0" smtClean="0"/>
-              <a:t xml:space="preserve">Collection </a:t>
+              <a:t>Collection </a:t>
             </a:r>
             <a:r>
               <a:rPr lang="en-US" dirty="0" err="1" smtClean="0"/>
@@ -990,11 +990,11 @@
             </a:r>
             <a:r>
               <a:rPr lang="en-US" dirty="0" smtClean="0"/>
-              <a:t xml:space="preserve"> pas</a:t>
+              <a:t> pas</a:t>
             </a:r>
             <a:r>
               <a:rPr lang="en-US" baseline="0" dirty="0" smtClean="0"/>
-              <a:t xml:space="preserve"> la </a:t>
+              <a:t> la </a:t>
             </a:r>
             <a:r>
               <a:rPr lang="en-US" baseline="0" dirty="0" err="1" smtClean="0"/>
@@ -1002,7 +1002,7 @@
             </a:r>
             <a:r>
               <a:rPr lang="en-US" baseline="0" dirty="0" smtClean="0"/>
-              <a:t xml:space="preserve"> 1.0</a:t>
+              <a:t> 1.0</a:t>
             </a:r>
           </a:p>
           <a:p>
@@ -1026,7 +1026,7 @@
                 <a:latin typeface="Times New Roman" panose="02020603050405020304" pitchFamily="18" charset="0"/>
                 <a:cs typeface="Times New Roman" panose="02020603050405020304" pitchFamily="18" charset="0"/>
               </a:rPr>
-              <a:t xml:space="preserve">, </a:t>
+              <a:t>, </a:t>
             </a:r>
             <a:r>
               <a:rPr lang="en-US" altLang="en-US" dirty="0" err="1" smtClean="0">
@@ -1046,7 +1046,7 @@
                 <a:latin typeface="Times New Roman" panose="02020603050405020304" pitchFamily="18" charset="0"/>
                 <a:cs typeface="Times New Roman" panose="02020603050405020304" pitchFamily="18" charset="0"/>
               </a:rPr>
-              <a:t xml:space="preserve"> </a:t>
+              <a:t> </a:t>
             </a:r>
             <a:r>
               <a:rPr lang="en-US" altLang="en-US" dirty="0" err="1" smtClean="0">
@@ -1066,7 +1066,7 @@
                 <a:latin typeface="Times New Roman" panose="02020603050405020304" pitchFamily="18" charset="0"/>
                 <a:cs typeface="Times New Roman" panose="02020603050405020304" pitchFamily="18" charset="0"/>
               </a:rPr>
-              <a:t xml:space="preserve"> </a:t>
+              <a:t> </a:t>
             </a:r>
             <a:r>
               <a:rPr lang="en-US" altLang="en-US" dirty="0" err="1" smtClean="0">
@@ -1086,7 +1086,7 @@
                 <a:latin typeface="Times New Roman" panose="02020603050405020304" pitchFamily="18" charset="0"/>
                 <a:cs typeface="Times New Roman" panose="02020603050405020304" pitchFamily="18" charset="0"/>
               </a:rPr>
-              <a:t xml:space="preserve"> </a:t>
+              <a:t> </a:t>
             </a:r>
             <a:r>
               <a:rPr lang="en-US" altLang="en-US" dirty="0" err="1" smtClean="0">
@@ -1106,7 +1106,7 @@
                 <a:latin typeface="Times New Roman" panose="02020603050405020304" pitchFamily="18" charset="0"/>
                 <a:cs typeface="Times New Roman" panose="02020603050405020304" pitchFamily="18" charset="0"/>
               </a:rPr>
-              <a:t xml:space="preserve"> un </a:t>
+              <a:t> un </a:t>
             </a:r>
             <a:r>
               <a:rPr lang="en-US" altLang="en-US" b="1" dirty="0" smtClean="0">
@@ -1116,7 +1116,7 @@
                 <a:latin typeface="Times New Roman" panose="02020603050405020304" pitchFamily="18" charset="0"/>
                 <a:cs typeface="Times New Roman" panose="02020603050405020304" pitchFamily="18" charset="0"/>
               </a:rPr>
-              <a:t xml:space="preserve">"cast" </a:t>
+              <a:t>"cast" </a:t>
             </a:r>
             <a:r>
               <a:rPr lang="en-US" altLang="en-US" dirty="0" err="1" smtClean="0">
@@ -1136,7 +1136,7 @@
                 <a:latin typeface="Times New Roman" panose="02020603050405020304" pitchFamily="18" charset="0"/>
                 <a:cs typeface="Times New Roman" panose="02020603050405020304" pitchFamily="18" charset="0"/>
               </a:rPr>
-              <a:t xml:space="preserve"> à </a:t>
+              <a:t> à </a:t>
             </a:r>
             <a:r>
               <a:rPr lang="en-US" altLang="en-US" dirty="0" err="1" smtClean="0">
@@ -1156,7 +1156,7 @@
                 <a:latin typeface="Times New Roman" panose="02020603050405020304" pitchFamily="18" charset="0"/>
                 <a:cs typeface="Times New Roman" panose="02020603050405020304" pitchFamily="18" charset="0"/>
               </a:rPr>
-              <a:t xml:space="preserve"> </a:t>
+              <a:t> </a:t>
             </a:r>
             <a:r>
               <a:rPr lang="en-US" altLang="en-US" dirty="0" err="1" smtClean="0">
@@ -1176,7 +1176,7 @@
                 <a:latin typeface="Times New Roman" panose="02020603050405020304" pitchFamily="18" charset="0"/>
                 <a:cs typeface="Times New Roman" panose="02020603050405020304" pitchFamily="18" charset="0"/>
               </a:rPr>
-              <a:t xml:space="preserve"> </a:t>
+              <a:t> </a:t>
             </a:r>
             <a:r>
               <a:rPr lang="en-US" altLang="en-US" dirty="0" err="1" smtClean="0">
@@ -1196,7 +1196,7 @@
                 <a:latin typeface="Times New Roman" panose="02020603050405020304" pitchFamily="18" charset="0"/>
                 <a:cs typeface="Times New Roman" panose="02020603050405020304" pitchFamily="18" charset="0"/>
               </a:rPr>
-              <a:t xml:space="preserve"> </a:t>
+              <a:t> </a:t>
             </a:r>
             <a:r>
               <a:rPr lang="en-US" altLang="en-US" dirty="0" err="1" smtClean="0">
@@ -1216,7 +1216,7 @@
                 <a:latin typeface="Times New Roman" panose="02020603050405020304" pitchFamily="18" charset="0"/>
                 <a:cs typeface="Times New Roman" panose="02020603050405020304" pitchFamily="18" charset="0"/>
               </a:rPr>
-              <a:t xml:space="preserve"> </a:t>
+              <a:t> </a:t>
             </a:r>
             <a:r>
               <a:rPr lang="en-US" altLang="en-US" dirty="0" err="1" smtClean="0">
@@ -1236,7 +1236,7 @@
                 <a:latin typeface="Times New Roman" panose="02020603050405020304" pitchFamily="18" charset="0"/>
                 <a:cs typeface="Times New Roman" panose="02020603050405020304" pitchFamily="18" charset="0"/>
               </a:rPr>
-              <a:t xml:space="preserve"> un </a:t>
+              <a:t> un </a:t>
             </a:r>
             <a:r>
               <a:rPr lang="en-US" altLang="en-US" dirty="0" err="1" smtClean="0">
@@ -1357,7 +1357,7 @@
             </a:r>
             <a:r>
               <a:rPr lang="en-US" baseline="0" dirty="0" smtClean="0"/>
-              <a:t xml:space="preserve"> </a:t>
+              <a:t> </a:t>
             </a:r>
             <a:r>
               <a:rPr lang="en-US" baseline="0" dirty="0" err="1" smtClean="0"/>
@@ -1365,7 +1365,7 @@
             </a:r>
             <a:r>
               <a:rPr lang="en-US" baseline="0" dirty="0" smtClean="0"/>
-              <a:t xml:space="preserve"> que Map fait </a:t>
+              <a:t> que Map fait </a:t>
             </a:r>
             <a:r>
               <a:rPr lang="en-US" baseline="0" dirty="0" err="1" smtClean="0"/>
@@ -1373,7 +1373,7 @@
             </a:r>
             <a:r>
               <a:rPr lang="en-US" baseline="0" dirty="0" smtClean="0"/>
-              <a:t xml:space="preserve"> du </a:t>
+              <a:t> du </a:t>
             </a:r>
             <a:r>
               <a:rPr lang="en-US" baseline="0" dirty="0" err="1" smtClean="0"/>
@@ -1381,7 +1381,7 @@
             </a:r>
             <a:r>
               <a:rPr lang="en-US" baseline="0" dirty="0" smtClean="0"/>
-              <a:t xml:space="preserve"> </a:t>
+              <a:t> </a:t>
             </a:r>
             <a:r>
               <a:rPr lang="en-US" baseline="0" dirty="0" err="1" smtClean="0"/>
@@ -1389,7 +1389,7 @@
             </a:r>
             <a:r>
               <a:rPr lang="en-US" baseline="0" dirty="0" smtClean="0"/>
-              <a:t xml:space="preserve"> </a:t>
+              <a:t> </a:t>
             </a:r>
             <a:r>
               <a:rPr lang="en-US" baseline="0" dirty="0" err="1" smtClean="0"/>
@@ -1397,7 +1397,7 @@
             </a:r>
             <a:r>
               <a:rPr lang="en-US" baseline="0" dirty="0" smtClean="0"/>
-              <a:t xml:space="preserve"> </a:t>
+              <a:t> </a:t>
             </a:r>
             <a:r>
               <a:rPr lang="en-US" baseline="0" dirty="0" err="1" smtClean="0"/>
@@ -1405,7 +1405,7 @@
             </a:r>
             <a:r>
               <a:rPr lang="en-US" baseline="0" dirty="0" smtClean="0"/>
-              <a:t xml:space="preserve"> pas de collections </a:t>
+              <a:t> pas de collections </a:t>
             </a:r>
             <a:endParaRPr lang="en-US" dirty="0"/>
           </a:p>
@@ -3707,7 +3707,7 @@
             <a:pPr lvl="2"/>
             <a:r>
               <a:rPr lang="fr-CA" dirty="0"/>
-              <a:t xml:space="preserve"> Troisième niveau</a:t>
+              <a:t> Troisième niveau</a:t>
             </a:r>
           </a:p>
           <a:p>
@@ -4584,7 +4584,7 @@
             </a:r>
             <a:r>
               <a:rPr lang="en-US" b="1" dirty="0" smtClean="0"/>
-              <a:t xml:space="preserve"> par:</a:t>
+              <a:t> par:</a:t>
             </a:r>
           </a:p>
           <a:p>
@@ -4727,7 +4727,7 @@
                   <a:srgbClr val="FF0000"/>
                 </a:solidFill>
               </a:rPr>
-              <a:t xml:space="preserve">III.1. </a:t>
+              <a:t>III.1. </a:t>
             </a:r>
             <a:r>
               <a:rPr lang="fr-CA" sz="2400" cap="none" dirty="0" err="1" smtClean="0">
@@ -4743,7 +4743,7 @@
                   <a:srgbClr val="FF0000"/>
                 </a:solidFill>
               </a:rPr>
-              <a:t xml:space="preserve"> des collections</a:t>
+              <a:t> des collections</a:t>
             </a:r>
             <a:endParaRPr lang="fr-CA" sz="2400" cap="none" dirty="0">
               <a:solidFill>
@@ -4976,7 +4976,7 @@
                 <a:latin typeface="+mn-lt"/>
                 <a:cs typeface="Times New Roman" panose="02020603050405020304" pitchFamily="18" charset="0"/>
               </a:rPr>
-              <a:t xml:space="preserve">III.2. Implementation </a:t>
+              <a:t>III.2. Implementation </a:t>
             </a:r>
             <a:r>
               <a:rPr lang="en-US" sz="2800" dirty="0" err="1" smtClean="0">
@@ -6921,7 +6921,7 @@
                   <a:srgbClr val="FF0000"/>
                 </a:solidFill>
               </a:rPr>
-              <a:t xml:space="preserve">IV. </a:t>
+              <a:t>IV. </a:t>
             </a:r>
             <a:r>
               <a:rPr lang="el-GR" sz="2400" cap="none" dirty="0" smtClean="0">
@@ -6929,7 +6929,7 @@
                   <a:srgbClr val="FF0000"/>
                 </a:solidFill>
               </a:rPr>
-              <a:t xml:space="preserve">λ  </a:t>
+              <a:t>λ  </a:t>
             </a:r>
             <a:r>
               <a:rPr lang="fr-CA" sz="2400" cap="none" dirty="0">
@@ -7141,7 +7141,7 @@
                 <a:ea typeface="Calibri" pitchFamily="34" charset="-122"/>
                 <a:cs typeface="Times New Roman" panose="02020603050405020304" pitchFamily="18" charset="0"/>
               </a:rPr>
-              <a:t xml:space="preserve">Une lambda est une fonction anonyme courte qu'on peut passer </a:t>
+              <a:t>Une lambda est une fonction anonyme courte qu'on peut passer </a:t>
             </a:r>
             <a:r>
               <a:rPr lang="en-US" sz="1400" dirty="0" err="1">
@@ -7163,7 +7163,7 @@
                 <a:ea typeface="Calibri" pitchFamily="34" charset="-122"/>
                 <a:cs typeface="Times New Roman" panose="02020603050405020304" pitchFamily="18" charset="0"/>
               </a:rPr>
-              <a:t xml:space="preserve"> argument. Elle remplace les classes anonymes pour les interfaces fonctionnelles (1 seule méthode abstraite).</a:t>
+              <a:t> argument. Elle remplace les classes anonymes pour les interfaces fonctionnelles (1 seule méthode abstraite).</a:t>
             </a:r>
             <a:endParaRPr lang="en-US" sz="1400" dirty="0">
               <a:latin typeface="Times New Roman" panose="02020603050405020304" pitchFamily="18" charset="0"/>
@@ -7356,7 +7356,7 @@
                 <a:latin typeface="Times New Roman" panose="02020603050405020304" pitchFamily="18" charset="0"/>
                 <a:cs typeface="Times New Roman" panose="02020603050405020304" pitchFamily="18" charset="0"/>
               </a:rPr>
-              <a:t xml:space="preserve">    @Override</a:t>
+              <a:t>    @Override</a:t>
             </a:r>
           </a:p>
         </p:txBody>
@@ -7390,7 +7390,7 @@
                 <a:latin typeface="Times New Roman" panose="02020603050405020304" pitchFamily="18" charset="0"/>
                 <a:cs typeface="Times New Roman" panose="02020603050405020304" pitchFamily="18" charset="0"/>
               </a:rPr>
-              <a:t xml:space="preserve">    public void run() {</a:t>
+              <a:t>    public void run() {</a:t>
             </a:r>
           </a:p>
         </p:txBody>
@@ -7424,7 +7424,7 @@
                 <a:latin typeface="Times New Roman" panose="02020603050405020304" pitchFamily="18" charset="0"/>
                 <a:cs typeface="Times New Roman" panose="02020603050405020304" pitchFamily="18" charset="0"/>
               </a:rPr>
-              <a:t xml:space="preserve">        System.out.println("Bonjour!");</a:t>
+              <a:t>        System.out.println("Bonjour!");</a:t>
             </a:r>
           </a:p>
         </p:txBody>
@@ -7458,7 +7458,7 @@
                 <a:latin typeface="Times New Roman" panose="02020603050405020304" pitchFamily="18" charset="0"/>
                 <a:cs typeface="Times New Roman" panose="02020603050405020304" pitchFamily="18" charset="0"/>
               </a:rPr>
-              <a:t xml:space="preserve">    }</a:t>
+              <a:t>    }</a:t>
             </a:r>
           </a:p>
         </p:txBody>
@@ -7648,7 +7648,7 @@
                 <a:ea typeface="Consolas" pitchFamily="34" charset="-122"/>
                 <a:cs typeface="Times New Roman" panose="02020603050405020304" pitchFamily="18" charset="0"/>
               </a:rPr>
-              <a:t xml:space="preserve">Runnable r2 = () -&gt; </a:t>
+              <a:t>Runnable r2 = () -&gt; </a:t>
             </a:r>
             <a:r>
               <a:rPr lang="en-US" sz="1600" dirty="0" err="1" smtClean="0">
@@ -8344,7 +8344,7 @@
                   <a:srgbClr val="FF0000"/>
                 </a:solidFill>
               </a:rPr>
-              <a:t xml:space="preserve">IV. </a:t>
+              <a:t>IV. </a:t>
             </a:r>
             <a:r>
               <a:rPr lang="en-US" sz="2400" cap="none" dirty="0" smtClean="0">
@@ -8360,7 +8360,7 @@
                   <a:srgbClr val="FF0000"/>
                 </a:solidFill>
               </a:rPr>
-              <a:t xml:space="preserve"> </a:t>
+              <a:t> </a:t>
             </a:r>
             <a:r>
               <a:rPr lang="fr-FR" sz="2000" cap="none" dirty="0" smtClean="0">
@@ -8368,7 +8368,7 @@
                   <a:srgbClr val="FF0000"/>
                 </a:solidFill>
               </a:rPr>
-              <a:t xml:space="preserve">λ  </a:t>
+              <a:t>λ  </a:t>
             </a:r>
             <a:r>
               <a:rPr lang="fr-FR" sz="2000" cap="none" dirty="0">
@@ -8910,7 +8910,7 @@
                 <a:ea typeface="Consolas" pitchFamily="34" charset="-122"/>
                 <a:cs typeface="Consolas" pitchFamily="34" charset="-120"/>
               </a:rPr>
-              <a:t xml:space="preserve">    int res = a + b;</a:t>
+              <a:t>    int res = a + b;</a:t>
             </a:r>
             <a:endParaRPr lang="en-US" sz="1400" dirty="0"/>
           </a:p>
@@ -8949,7 +8949,7 @@
                 <a:ea typeface="Consolas" pitchFamily="34" charset="-122"/>
                 <a:cs typeface="Consolas" pitchFamily="34" charset="-120"/>
               </a:rPr>
-              <a:t xml:space="preserve">    return res;</a:t>
+              <a:t>    return res;</a:t>
             </a:r>
             <a:endParaRPr lang="en-US" sz="1400" dirty="0"/>
           </a:p>
@@ -11116,7 +11116,7 @@
                   <a:srgbClr val="FF0000"/>
                 </a:solidFill>
               </a:rPr>
-              <a:t xml:space="preserve">IV. </a:t>
+              <a:t>IV. </a:t>
             </a:r>
             <a:r>
               <a:rPr lang="en-US" sz="2400" cap="none" dirty="0" smtClean="0">
@@ -11133,7 +11133,7 @@
                 </a:solidFill>
                 <a:latin typeface="+mn-lt"/>
               </a:rPr>
-              <a:t xml:space="preserve"> </a:t>
+              <a:t> </a:t>
             </a:r>
             <a:r>
               <a:rPr lang="fr-FR" sz="2400" dirty="0">
@@ -11437,7 +11437,7 @@
                 <a:ea typeface="Calibri" pitchFamily="34" charset="-122"/>
                 <a:cs typeface="Calibri" pitchFamily="34" charset="-120"/>
               </a:rPr>
-              <a:t xml:space="preserve">Un Stream est une séquence d'éléments sur laquelle on applique des opérations </a:t>
+              <a:t>Un Stream est une séquence d'éléments sur laquelle on applique des opérations </a:t>
             </a:r>
             <a:r>
               <a:rPr lang="en-US" sz="1400" dirty="0" err="1">
@@ -11459,7 +11459,7 @@
                 <a:ea typeface="Calibri" pitchFamily="34" charset="-122"/>
                 <a:cs typeface="Calibri" pitchFamily="34" charset="-120"/>
               </a:rPr>
-              <a:t xml:space="preserve"> chaîne (pipeline). Il ne modifie pas la collection source — il produit un nouveau résultat.</a:t>
+              <a:t> chaîne (pipeline). Il ne modifie pas la collection source — il produit un nouveau résultat.</a:t>
             </a:r>
             <a:endParaRPr lang="en-US" sz="1400" dirty="0"/>
           </a:p>
@@ -13020,7 +13020,7 @@
                 <a:ea typeface="Calibri" pitchFamily="34" charset="-122"/>
                 <a:cs typeface="Calibri" pitchFamily="34" charset="-120"/>
               </a:rPr>
-              <a:t xml:space="preserve">Collecte </a:t>
+              <a:t>Collecte </a:t>
             </a:r>
             <a:r>
               <a:rPr lang="en-US" sz="1400" dirty="0" err="1">
@@ -13042,7 +13042,7 @@
                 <a:ea typeface="Calibri" pitchFamily="34" charset="-122"/>
                 <a:cs typeface="Calibri" pitchFamily="34" charset="-120"/>
               </a:rPr>
-              <a:t xml:space="preserve"> List, Set, Map...</a:t>
+              <a:t> List, Set, Map...</a:t>
             </a:r>
             <a:endParaRPr lang="en-US" sz="1400" dirty="0"/>
           </a:p>
@@ -15460,7 +15460,7 @@
                   <a:srgbClr val="FF0000"/>
                 </a:solidFill>
               </a:rPr>
-              <a:t xml:space="preserve">IV. </a:t>
+              <a:t>IV. </a:t>
             </a:r>
             <a:r>
               <a:rPr lang="en-US" sz="2400" cap="none" dirty="0" smtClean="0">
@@ -15477,7 +15477,7 @@
                 </a:solidFill>
                 <a:latin typeface="+mn-lt"/>
               </a:rPr>
-              <a:t xml:space="preserve">  </a:t>
+              <a:t>  </a:t>
             </a:r>
             <a:r>
               <a:rPr lang="fr-FR" sz="2400" dirty="0">
@@ -15590,7 +15590,7 @@
                 <a:ea typeface="Calibri" pitchFamily="34" charset="-122"/>
                 <a:cs typeface="Times New Roman" panose="02020603050405020304" pitchFamily="18" charset="0"/>
               </a:rPr>
-              <a:t xml:space="preserve">👨‍💼  Scénario : Filtrer les employés seniors (salaire &gt; 50 000€), extraire leurs noms, trier et afficher — </a:t>
+              <a:t>👨‍💼  Scénario : Filtrer les employés seniors (salaire &gt; 50 000€), extraire leurs noms, trier et afficher — </a:t>
             </a:r>
             <a:r>
               <a:rPr lang="en-US" sz="1400" dirty="0" err="1">
@@ -15612,7 +15612,7 @@
                 <a:ea typeface="Calibri" pitchFamily="34" charset="-122"/>
                 <a:cs typeface="Times New Roman" panose="02020603050405020304" pitchFamily="18" charset="0"/>
               </a:rPr>
-              <a:t xml:space="preserve"> quelques lignes avec Lambda + Stream.</a:t>
+              <a:t> quelques lignes avec Lambda + Stream.</a:t>
             </a:r>
             <a:endParaRPr lang="en-US" sz="1400" dirty="0">
               <a:latin typeface="Times New Roman" panose="02020603050405020304" pitchFamily="18" charset="0"/>
@@ -15759,7 +15759,7 @@
                 <a:ea typeface="Consolas" pitchFamily="34" charset="-122"/>
                 <a:cs typeface="Consolas" pitchFamily="34" charset="-120"/>
               </a:rPr>
-              <a:t xml:space="preserve">    </a:t>
+              <a:t>    </a:t>
             </a:r>
             <a:r>
               <a:rPr lang="en-US" sz="1400" b="1" dirty="0">
@@ -15813,7 +15813,7 @@
                 <a:ea typeface="Consolas" pitchFamily="34" charset="-122"/>
                 <a:cs typeface="Consolas" pitchFamily="34" charset="-120"/>
               </a:rPr>
-              <a:t xml:space="preserve">    </a:t>
+              <a:t>    </a:t>
             </a:r>
             <a:r>
               <a:rPr lang="en-US" sz="1400" b="1" dirty="0">
@@ -15867,7 +15867,7 @@
                 <a:ea typeface="Consolas" pitchFamily="34" charset="-122"/>
                 <a:cs typeface="Consolas" pitchFamily="34" charset="-120"/>
               </a:rPr>
-              <a:t xml:space="preserve">    </a:t>
+              <a:t>    </a:t>
             </a:r>
             <a:r>
               <a:rPr lang="en-US" sz="1400" b="1" dirty="0">
@@ -16070,7 +16070,7 @@
                 <a:ea typeface="Consolas" pitchFamily="34" charset="-122"/>
                 <a:cs typeface="Consolas" pitchFamily="34" charset="-120"/>
               </a:rPr>
-              <a:t xml:space="preserve">    .stream()</a:t>
+              <a:t>    .stream()</a:t>
             </a:r>
             <a:endParaRPr lang="en-US" sz="1400" b="1" dirty="0"/>
           </a:p>
@@ -16109,7 +16109,7 @@
                 <a:ea typeface="Consolas" pitchFamily="34" charset="-122"/>
                 <a:cs typeface="Consolas" pitchFamily="34" charset="-120"/>
               </a:rPr>
-              <a:t xml:space="preserve">    .filter(e -&gt; e.salaire &gt; 50_000)</a:t>
+              <a:t>    .filter(e -&gt; e.salaire &gt; 50_000)</a:t>
             </a:r>
             <a:endParaRPr lang="en-US" sz="1400" b="1" dirty="0"/>
           </a:p>
@@ -16148,7 +16148,7 @@
                 <a:ea typeface="Consolas" pitchFamily="34" charset="-122"/>
                 <a:cs typeface="Consolas" pitchFamily="34" charset="-120"/>
               </a:rPr>
-              <a:t xml:space="preserve">    .</a:t>
+              <a:t>    .</a:t>
             </a:r>
             <a:r>
               <a:rPr lang="en-US" sz="1400" b="1" dirty="0">
@@ -16202,7 +16202,7 @@
                 <a:ea typeface="Consolas" pitchFamily="34" charset="-122"/>
                 <a:cs typeface="Consolas" pitchFamily="34" charset="-120"/>
               </a:rPr>
-              <a:t xml:space="preserve">        e -&gt; e.nom))</a:t>
+              <a:t>        e -&gt; e.nom))</a:t>
             </a:r>
             <a:endParaRPr lang="en-US" sz="1400" b="1" dirty="0">
               <a:solidFill>
@@ -16245,7 +16245,7 @@
                 <a:ea typeface="Consolas" pitchFamily="34" charset="-122"/>
                 <a:cs typeface="Consolas" pitchFamily="34" charset="-120"/>
               </a:rPr>
-              <a:t xml:space="preserve">    .map(e -&gt; e.nom)</a:t>
+              <a:t>    .map(e -&gt; e.nom)</a:t>
             </a:r>
             <a:endParaRPr lang="en-US" sz="1400" b="1" dirty="0"/>
           </a:p>
@@ -16284,7 +16284,7 @@
                 <a:ea typeface="Consolas" pitchFamily="34" charset="-122"/>
                 <a:cs typeface="Consolas" pitchFamily="34" charset="-120"/>
               </a:rPr>
-              <a:t xml:space="preserve">    .collect(Collectors.toList());</a:t>
+              <a:t>    .collect(Collectors.toList());</a:t>
             </a:r>
             <a:endParaRPr lang="en-US" sz="1400" b="1" dirty="0"/>
           </a:p>
@@ -16433,7 +16433,7 @@
                 <a:ea typeface="Consolas" pitchFamily="34" charset="-122"/>
                 <a:cs typeface="Consolas" pitchFamily="34" charset="-120"/>
               </a:rPr>
-              <a:t xml:space="preserve">    System.out::println);</a:t>
+              <a:t>    System.out::println);</a:t>
             </a:r>
             <a:endParaRPr lang="en-US" sz="1400" b="1" dirty="0"/>
           </a:p>
@@ -16974,7 +16974,7 @@
                 <a:ea typeface="Calibri" pitchFamily="34" charset="-122"/>
                 <a:cs typeface="Times New Roman" panose="02020603050405020304" pitchFamily="18" charset="0"/>
               </a:rPr>
-              <a:t xml:space="preserve">Transforme chaque Employe </a:t>
+              <a:t>Transforme chaque Employe </a:t>
             </a:r>
             <a:r>
               <a:rPr lang="en-US" sz="1200" dirty="0" err="1">
@@ -16996,7 +16996,7 @@
                 <a:ea typeface="Calibri" pitchFamily="34" charset="-122"/>
                 <a:cs typeface="Times New Roman" panose="02020603050405020304" pitchFamily="18" charset="0"/>
               </a:rPr>
-              <a:t xml:space="preserve"> String (son nom)</a:t>
+              <a:t> String (son nom)</a:t>
             </a:r>
             <a:endParaRPr lang="en-US" sz="1200" dirty="0">
               <a:latin typeface="Times New Roman" panose="02020603050405020304" pitchFamily="18" charset="0"/>
@@ -18471,7 +18471,7 @@
                 <a:ea typeface="Consolas" pitchFamily="34" charset="-122"/>
                 <a:cs typeface="Consolas" pitchFamily="34" charset="-120"/>
               </a:rPr>
-              <a:t xml:space="preserve">  private String marque = "Toyota";</a:t>
+              <a:t>  private String marque = "Toyota";</a:t>
             </a:r>
             <a:endParaRPr lang="en-US" sz="1400" dirty="0">
               <a:solidFill>
@@ -18492,7 +18492,7 @@
                 <a:ea typeface="Consolas" pitchFamily="34" charset="-122"/>
                 <a:cs typeface="Consolas" pitchFamily="34" charset="-120"/>
               </a:rPr>
-              <a:t xml:space="preserve">  private int vitesse = 0;</a:t>
+              <a:t>  private int vitesse = 0;</a:t>
             </a:r>
             <a:endParaRPr lang="en-US" sz="1400" dirty="0">
               <a:solidFill>
@@ -18523,7 +18523,7 @@
                 <a:ea typeface="Consolas" pitchFamily="34" charset="-122"/>
                 <a:cs typeface="Consolas" pitchFamily="34" charset="-120"/>
               </a:rPr>
-              <a:t xml:space="preserve">  // ──── Inner Class ────</a:t>
+              <a:t>  // ──── Inner Class ────</a:t>
             </a:r>
             <a:endParaRPr lang="en-US" sz="1400" dirty="0">
               <a:solidFill>
@@ -18544,7 +18544,7 @@
                 <a:ea typeface="Consolas" pitchFamily="34" charset="-122"/>
                 <a:cs typeface="Consolas" pitchFamily="34" charset="-120"/>
               </a:rPr>
-              <a:t xml:space="preserve">  class Moteur {</a:t>
+              <a:t>  class Moteur {</a:t>
             </a:r>
             <a:endParaRPr lang="en-US" sz="1400" dirty="0">
               <a:solidFill>
@@ -18565,7 +18565,7 @@
                 <a:ea typeface="Consolas" pitchFamily="34" charset="-122"/>
                 <a:cs typeface="Consolas" pitchFamily="34" charset="-120"/>
               </a:rPr>
-              <a:t xml:space="preserve">    public void demarrer() {</a:t>
+              <a:t>    public void demarrer() {</a:t>
             </a:r>
             <a:endParaRPr lang="en-US" sz="1400" dirty="0">
               <a:solidFill>
@@ -18586,7 +18586,7 @@
                 <a:ea typeface="Consolas" pitchFamily="34" charset="-122"/>
                 <a:cs typeface="Consolas" pitchFamily="34" charset="-120"/>
               </a:rPr>
-              <a:t xml:space="preserve">      // Accès direct aux membres privés de Voiture</a:t>
+              <a:t>      // Accès direct aux membres privés de Voiture</a:t>
             </a:r>
             <a:endParaRPr lang="en-US" sz="1400" dirty="0">
               <a:solidFill>
@@ -18607,7 +18607,7 @@
                 <a:ea typeface="Consolas" pitchFamily="34" charset="-122"/>
                 <a:cs typeface="Consolas" pitchFamily="34" charset="-120"/>
               </a:rPr>
-              <a:t xml:space="preserve">      System.out.println(marque + " démarre...");</a:t>
+              <a:t>      System.out.println(marque + " démarre...");</a:t>
             </a:r>
             <a:endParaRPr lang="en-US" sz="1400" dirty="0">
               <a:solidFill>
@@ -18628,7 +18628,7 @@
                 <a:ea typeface="Consolas" pitchFamily="34" charset="-122"/>
                 <a:cs typeface="Consolas" pitchFamily="34" charset="-120"/>
               </a:rPr>
-              <a:t xml:space="preserve">      vitesse = 10;</a:t>
+              <a:t>      vitesse = 10;</a:t>
             </a:r>
             <a:endParaRPr lang="en-US" sz="1400" dirty="0">
               <a:solidFill>
@@ -18649,7 +18649,7 @@
                 <a:ea typeface="Consolas" pitchFamily="34" charset="-122"/>
                 <a:cs typeface="Consolas" pitchFamily="34" charset="-120"/>
               </a:rPr>
-              <a:t xml:space="preserve">    }</a:t>
+              <a:t>    }</a:t>
             </a:r>
             <a:endParaRPr lang="en-US" sz="1400" dirty="0">
               <a:solidFill>
@@ -18670,7 +18670,7 @@
                 <a:ea typeface="Consolas" pitchFamily="34" charset="-122"/>
                 <a:cs typeface="Consolas" pitchFamily="34" charset="-120"/>
               </a:rPr>
-              <a:t xml:space="preserve">    public void accelerer(int delta) {</a:t>
+              <a:t>    public void accelerer(int delta) {</a:t>
             </a:r>
             <a:endParaRPr lang="en-US" sz="1400" dirty="0">
               <a:solidFill>
@@ -18691,7 +18691,7 @@
                 <a:ea typeface="Consolas" pitchFamily="34" charset="-122"/>
                 <a:cs typeface="Consolas" pitchFamily="34" charset="-120"/>
               </a:rPr>
-              <a:t xml:space="preserve">      vitesse += delta;</a:t>
+              <a:t>      vitesse += delta;</a:t>
             </a:r>
             <a:endParaRPr lang="en-US" sz="1400" dirty="0">
               <a:solidFill>
@@ -18712,7 +18712,7 @@
                 <a:ea typeface="Consolas" pitchFamily="34" charset="-122"/>
                 <a:cs typeface="Consolas" pitchFamily="34" charset="-120"/>
               </a:rPr>
-              <a:t xml:space="preserve">      System.out.println("Vitesse: " + vitesse + " km/h");</a:t>
+              <a:t>      System.out.println("Vitesse: " + vitesse + " km/h");</a:t>
             </a:r>
             <a:endParaRPr lang="en-US" sz="1400" dirty="0">
               <a:solidFill>
@@ -18733,7 +18733,7 @@
                 <a:ea typeface="Consolas" pitchFamily="34" charset="-122"/>
                 <a:cs typeface="Consolas" pitchFamily="34" charset="-120"/>
               </a:rPr>
-              <a:t xml:space="preserve">    }</a:t>
+              <a:t>    }</a:t>
             </a:r>
             <a:endParaRPr lang="en-US" sz="1400" dirty="0">
               <a:solidFill>
@@ -18754,7 +18754,7 @@
                 <a:ea typeface="Consolas" pitchFamily="34" charset="-122"/>
                 <a:cs typeface="Consolas" pitchFamily="34" charset="-120"/>
               </a:rPr>
-              <a:t xml:space="preserve">  }</a:t>
+              <a:t>  }</a:t>
             </a:r>
             <a:endParaRPr lang="en-US" sz="1400" dirty="0">
               <a:solidFill>
@@ -18785,7 +18785,7 @@
                 <a:ea typeface="Consolas" pitchFamily="34" charset="-122"/>
                 <a:cs typeface="Consolas" pitchFamily="34" charset="-120"/>
               </a:rPr>
-              <a:t xml:space="preserve">  public void rouler() {</a:t>
+              <a:t>  public void rouler() {</a:t>
             </a:r>
             <a:endParaRPr lang="en-US" sz="1400" dirty="0">
               <a:solidFill>
@@ -18806,7 +18806,7 @@
                 <a:ea typeface="Consolas" pitchFamily="34" charset="-122"/>
                 <a:cs typeface="Consolas" pitchFamily="34" charset="-120"/>
               </a:rPr>
-              <a:t xml:space="preserve">    Moteur m = new Moteur(); // Instanciation depuis l'extérieur</a:t>
+              <a:t>    Moteur m = new Moteur(); // Instanciation depuis l'extérieur</a:t>
             </a:r>
             <a:endParaRPr lang="en-US" sz="1400" dirty="0">
               <a:solidFill>
@@ -18827,7 +18827,7 @@
                 <a:ea typeface="Consolas" pitchFamily="34" charset="-122"/>
                 <a:cs typeface="Consolas" pitchFamily="34" charset="-120"/>
               </a:rPr>
-              <a:t xml:space="preserve">    m.demarrer();</a:t>
+              <a:t>    m.demarrer();</a:t>
             </a:r>
             <a:endParaRPr lang="en-US" sz="1400" dirty="0">
               <a:solidFill>
@@ -18848,7 +18848,7 @@
                 <a:ea typeface="Consolas" pitchFamily="34" charset="-122"/>
                 <a:cs typeface="Consolas" pitchFamily="34" charset="-120"/>
               </a:rPr>
-              <a:t xml:space="preserve">    m.accelerer(50);</a:t>
+              <a:t>    m.accelerer(50);</a:t>
             </a:r>
             <a:endParaRPr lang="en-US" sz="1400" dirty="0">
               <a:solidFill>
@@ -18869,7 +18869,7 @@
                 <a:ea typeface="Consolas" pitchFamily="34" charset="-122"/>
                 <a:cs typeface="Consolas" pitchFamily="34" charset="-120"/>
               </a:rPr>
-              <a:t xml:space="preserve">  }</a:t>
+              <a:t>  }</a:t>
             </a:r>
             <a:endParaRPr lang="en-US" sz="1400" dirty="0">
               <a:solidFill>
@@ -18900,7 +18900,7 @@
                 <a:ea typeface="Consolas" pitchFamily="34" charset="-122"/>
                 <a:cs typeface="Consolas" pitchFamily="34" charset="-120"/>
               </a:rPr>
-              <a:t xml:space="preserve">  </a:t>
+              <a:t>  </a:t>
             </a:r>
             <a:endParaRPr lang="en-US" sz="1400" dirty="0">
               <a:solidFill>
@@ -19680,7 +19680,7 @@
                 <a:ea typeface="Calibri" pitchFamily="34" charset="-122"/>
                 <a:cs typeface="Calibri" pitchFamily="34" charset="-120"/>
               </a:rPr>
-              <a:t xml:space="preserve">Sans nom, déclarée et instanciée </a:t>
+              <a:t>Sans nom, déclarée et instanciée </a:t>
             </a:r>
             <a:r>
               <a:rPr lang="en-US" sz="1400" dirty="0" err="1">
@@ -19702,7 +19702,7 @@
                 <a:ea typeface="Calibri" pitchFamily="34" charset="-122"/>
                 <a:cs typeface="Calibri" pitchFamily="34" charset="-120"/>
               </a:rPr>
-              <a:t xml:space="preserve"> une seule expression. Usage unique.</a:t>
+              <a:t> une seule expression. Usage unique.</a:t>
             </a:r>
             <a:endParaRPr lang="en-US" sz="1400" dirty="0"/>
           </a:p>
@@ -20047,7 +20047,7 @@
                 <a:ea typeface="Consolas" pitchFamily="34" charset="-122"/>
                 <a:cs typeface="Times New Roman" panose="02020603050405020304" pitchFamily="18" charset="0"/>
               </a:rPr>
-              <a:t xml:space="preserve">  </a:t>
+              <a:t>  </a:t>
             </a:r>
             <a:r>
               <a:rPr lang="en-US" b="1" dirty="0">
@@ -20128,7 +20128,7 @@
                 <a:ea typeface="Consolas" pitchFamily="34" charset="-122"/>
                 <a:cs typeface="Times New Roman" panose="02020603050405020304" pitchFamily="18" charset="0"/>
               </a:rPr>
-              <a:t xml:space="preserve">  // </a:t>
+              <a:t>  // </a:t>
             </a:r>
             <a:r>
               <a:rPr lang="en-US" b="1" dirty="0">
@@ -20181,7 +20181,7 @@
                 <a:ea typeface="Consolas" pitchFamily="34" charset="-122"/>
                 <a:cs typeface="Times New Roman" panose="02020603050405020304" pitchFamily="18" charset="0"/>
               </a:rPr>
-              <a:t xml:space="preserve">  class Moteur {</a:t>
+              <a:t>  class Moteur {</a:t>
             </a:r>
             <a:endParaRPr lang="en-US" dirty="0">
               <a:latin typeface="Times New Roman" panose="02020603050405020304" pitchFamily="18" charset="0"/>
@@ -20223,7 +20223,7 @@
                 <a:ea typeface="Consolas" pitchFamily="34" charset="-122"/>
                 <a:cs typeface="Times New Roman" panose="02020603050405020304" pitchFamily="18" charset="0"/>
               </a:rPr>
-              <a:t xml:space="preserve">    int chevaux</a:t>
+              <a:t>    int chevaux</a:t>
             </a:r>
             <a:r>
               <a:rPr lang="en-US" dirty="0">
@@ -20307,7 +20307,7 @@
                 <a:ea typeface="Consolas" pitchFamily="34" charset="-122"/>
                 <a:cs typeface="Times New Roman" panose="02020603050405020304" pitchFamily="18" charset="0"/>
               </a:rPr>
-              <a:t xml:space="preserve">    </a:t>
+              <a:t>    </a:t>
             </a:r>
             <a:r>
               <a:rPr lang="en-US" b="1" dirty="0">
@@ -20363,7 +20363,7 @@
                 <a:ea typeface="Consolas" pitchFamily="34" charset="-122"/>
                 <a:cs typeface="Times New Roman" panose="02020603050405020304" pitchFamily="18" charset="0"/>
               </a:rPr>
-              <a:t xml:space="preserve">      // accède à marque</a:t>
+              <a:t>      // accède à marque</a:t>
             </a:r>
             <a:endParaRPr lang="en-US" dirty="0">
               <a:latin typeface="Times New Roman" panose="02020603050405020304" pitchFamily="18" charset="0"/>
@@ -20405,7 +20405,7 @@
                 <a:ea typeface="Consolas" pitchFamily="34" charset="-122"/>
                 <a:cs typeface="Times New Roman" panose="02020603050405020304" pitchFamily="18" charset="0"/>
               </a:rPr>
-              <a:t xml:space="preserve">      </a:t>
+              <a:t>      </a:t>
             </a:r>
             <a:r>
               <a:rPr lang="en-US" dirty="0">
@@ -20455,7 +20455,7 @@
                 <a:ea typeface="Consolas" pitchFamily="34" charset="-122"/>
                 <a:cs typeface="Times New Roman" panose="02020603050405020304" pitchFamily="18" charset="0"/>
               </a:rPr>
-              <a:t xml:space="preserve">        </a:t>
+              <a:t>        </a:t>
             </a:r>
             <a:r>
               <a:rPr lang="en-US" b="1" dirty="0">
@@ -20505,7 +20505,7 @@
                 <a:ea typeface="Consolas" pitchFamily="34" charset="-122"/>
                 <a:cs typeface="Times New Roman" panose="02020603050405020304" pitchFamily="18" charset="0"/>
               </a:rPr>
-              <a:t xml:space="preserve">    }</a:t>
+              <a:t>    }</a:t>
             </a:r>
             <a:endParaRPr lang="en-US" dirty="0">
               <a:latin typeface="Times New Roman" panose="02020603050405020304" pitchFamily="18" charset="0"/>
@@ -20547,7 +20547,7 @@
                 <a:ea typeface="Consolas" pitchFamily="34" charset="-122"/>
                 <a:cs typeface="Times New Roman" panose="02020603050405020304" pitchFamily="18" charset="0"/>
               </a:rPr>
-              <a:t xml:space="preserve">  }</a:t>
+              <a:t>  }</a:t>
             </a:r>
             <a:endParaRPr lang="en-US" dirty="0">
               <a:latin typeface="Times New Roman" panose="02020603050405020304" pitchFamily="18" charset="0"/>
@@ -20760,7 +20760,7 @@
                 <a:ea typeface="Consolas" pitchFamily="34" charset="-122"/>
                 <a:cs typeface="Times New Roman" panose="02020603050405020304" pitchFamily="18" charset="0"/>
               </a:rPr>
-              <a:t xml:space="preserve">  </a:t>
+              <a:t>  </a:t>
             </a:r>
             <a:r>
               <a:rPr lang="en-US" b="1" dirty="0">
@@ -20841,7 +20841,7 @@
                 <a:ea typeface="Consolas" pitchFamily="34" charset="-122"/>
                 <a:cs typeface="Times New Roman" panose="02020603050405020304" pitchFamily="18" charset="0"/>
               </a:rPr>
-              <a:t xml:space="preserve">  // </a:t>
+              <a:t>  // </a:t>
             </a:r>
             <a:r>
               <a:rPr lang="en-US" b="1" dirty="0">
@@ -20894,7 +20894,7 @@
                 <a:ea typeface="Consolas" pitchFamily="34" charset="-122"/>
                 <a:cs typeface="Times New Roman" panose="02020603050405020304" pitchFamily="18" charset="0"/>
               </a:rPr>
-              <a:t xml:space="preserve">  static class Etudiant {</a:t>
+              <a:t>  static class Etudiant {</a:t>
             </a:r>
             <a:endParaRPr lang="en-US" b="1" dirty="0">
               <a:latin typeface="Times New Roman" panose="02020603050405020304" pitchFamily="18" charset="0"/>
@@ -20933,7 +20933,7 @@
                 <a:ea typeface="Consolas" pitchFamily="34" charset="-122"/>
                 <a:cs typeface="Times New Roman" panose="02020603050405020304" pitchFamily="18" charset="0"/>
               </a:rPr>
-              <a:t xml:space="preserve">    String prenom;</a:t>
+              <a:t>    String prenom;</a:t>
             </a:r>
             <a:endParaRPr lang="en-US" b="1" dirty="0">
               <a:latin typeface="Times New Roman" panose="02020603050405020304" pitchFamily="18" charset="0"/>
@@ -20975,7 +20975,7 @@
                 <a:ea typeface="Consolas" pitchFamily="34" charset="-122"/>
                 <a:cs typeface="Times New Roman" panose="02020603050405020304" pitchFamily="18" charset="0"/>
               </a:rPr>
-              <a:t xml:space="preserve">    </a:t>
+              <a:t>    </a:t>
             </a:r>
             <a:r>
               <a:rPr lang="en-US" b="1" dirty="0">
@@ -21056,7 +21056,7 @@
                 <a:ea typeface="Consolas" pitchFamily="34" charset="-122"/>
                 <a:cs typeface="Times New Roman" panose="02020603050405020304" pitchFamily="18" charset="0"/>
               </a:rPr>
-              <a:t xml:space="preserve">    void afficher() {</a:t>
+              <a:t>    void afficher() {</a:t>
             </a:r>
             <a:endParaRPr lang="en-US" b="1" dirty="0">
               <a:solidFill>
@@ -21101,7 +21101,7 @@
                 <a:ea typeface="Consolas" pitchFamily="34" charset="-122"/>
                 <a:cs typeface="Times New Roman" panose="02020603050405020304" pitchFamily="18" charset="0"/>
               </a:rPr>
-              <a:t xml:space="preserve">      </a:t>
+              <a:t>      </a:t>
             </a:r>
             <a:r>
               <a:rPr lang="en-US" b="1" dirty="0">
@@ -21151,7 +21151,7 @@
                 <a:ea typeface="Consolas" pitchFamily="34" charset="-122"/>
                 <a:cs typeface="Times New Roman" panose="02020603050405020304" pitchFamily="18" charset="0"/>
               </a:rPr>
-              <a:t xml:space="preserve">        </a:t>
+              <a:t>        </a:t>
             </a:r>
             <a:r>
               <a:rPr lang="en-US" b="1" dirty="0">
@@ -21204,7 +21204,7 @@
                 <a:ea typeface="Consolas" pitchFamily="34" charset="-122"/>
                 <a:cs typeface="Times New Roman" panose="02020603050405020304" pitchFamily="18" charset="0"/>
               </a:rPr>
-              <a:t xml:space="preserve">    }</a:t>
+              <a:t>    }</a:t>
             </a:r>
             <a:endParaRPr lang="en-US" dirty="0">
               <a:latin typeface="Times New Roman" panose="02020603050405020304" pitchFamily="18" charset="0"/>
@@ -21246,7 +21246,7 @@
                 <a:ea typeface="Consolas" pitchFamily="34" charset="-122"/>
                 <a:cs typeface="Times New Roman" panose="02020603050405020304" pitchFamily="18" charset="0"/>
               </a:rPr>
-              <a:t xml:space="preserve">  }</a:t>
+              <a:t>  }</a:t>
             </a:r>
             <a:endParaRPr lang="en-US" dirty="0">
               <a:latin typeface="Times New Roman" panose="02020603050405020304" pitchFamily="18" charset="0"/>
@@ -21674,7 +21674,7 @@
                 <a:ea typeface="Consolas" pitchFamily="34" charset="-122"/>
                 <a:cs typeface="Consolas" pitchFamily="34" charset="-120"/>
               </a:rPr>
-              <a:t xml:space="preserve">  </a:t>
+              <a:t>  </a:t>
             </a:r>
             <a:r>
               <a:rPr lang="en-US" sz="1600" b="1" dirty="0">
@@ -21721,7 +21721,7 @@
                 <a:ea typeface="Consolas" pitchFamily="34" charset="-122"/>
                 <a:cs typeface="Consolas" pitchFamily="34" charset="-120"/>
               </a:rPr>
-              <a:t xml:space="preserve">  </a:t>
+              <a:t>  </a:t>
             </a:r>
             <a:r>
               <a:rPr lang="en-US" sz="1600" b="1" dirty="0">
@@ -21796,7 +21796,7 @@
                 <a:ea typeface="Consolas" pitchFamily="34" charset="-122"/>
                 <a:cs typeface="Consolas" pitchFamily="34" charset="-120"/>
               </a:rPr>
-              <a:t xml:space="preserve">  // Classe interne membre</a:t>
+              <a:t>  // Classe interne membre</a:t>
             </a:r>
             <a:endParaRPr lang="en-US" sz="1600" b="1" dirty="0"/>
           </a:p>
@@ -21835,7 +21835,7 @@
                 <a:ea typeface="Consolas" pitchFamily="34" charset="-122"/>
                 <a:cs typeface="Consolas" pitchFamily="34" charset="-120"/>
               </a:rPr>
-              <a:t xml:space="preserve">  class Transaction {</a:t>
+              <a:t>  class Transaction {</a:t>
             </a:r>
             <a:endParaRPr lang="en-US" sz="1600" b="1" dirty="0"/>
           </a:p>
@@ -21874,7 +21874,7 @@
                 <a:ea typeface="Consolas" pitchFamily="34" charset="-122"/>
                 <a:cs typeface="Consolas" pitchFamily="34" charset="-120"/>
               </a:rPr>
-              <a:t xml:space="preserve">    </a:t>
+              <a:t>    </a:t>
             </a:r>
             <a:r>
               <a:rPr lang="en-US" sz="1600" b="1" dirty="0">
@@ -21918,7 +21918,7 @@
                 <a:ea typeface="Consolas" pitchFamily="34" charset="-122"/>
                 <a:cs typeface="Consolas" pitchFamily="34" charset="-120"/>
               </a:rPr>
-              <a:t xml:space="preserve">    String type; // "debit"/"credit"</a:t>
+              <a:t>    String type; // "debit"/"credit"</a:t>
             </a:r>
             <a:endParaRPr lang="en-US" sz="1600" b="1" dirty="0"/>
           </a:p>
@@ -21985,7 +21985,7 @@
                 <a:ea typeface="Consolas" pitchFamily="34" charset="-122"/>
                 <a:cs typeface="Consolas" pitchFamily="34" charset="-120"/>
               </a:rPr>
-              <a:t xml:space="preserve">    </a:t>
+              <a:t>    </a:t>
             </a:r>
             <a:r>
               <a:rPr lang="en-US" sz="1600" b="1" dirty="0">
@@ -22039,7 +22039,7 @@
                 <a:ea typeface="Consolas" pitchFamily="34" charset="-122"/>
                 <a:cs typeface="Consolas" pitchFamily="34" charset="-120"/>
               </a:rPr>
-              <a:t xml:space="preserve">      if (type.equals("credit")) {</a:t>
+              <a:t>      if (type.equals("credit")) {</a:t>
             </a:r>
             <a:endParaRPr lang="en-US" sz="1600" b="1" dirty="0">
               <a:solidFill>
@@ -22082,7 +22082,7 @@
                 <a:ea typeface="Consolas" pitchFamily="34" charset="-122"/>
                 <a:cs typeface="Consolas" pitchFamily="34" charset="-120"/>
               </a:rPr>
-              <a:t xml:space="preserve">        </a:t>
+              <a:t>        </a:t>
             </a:r>
             <a:r>
               <a:rPr lang="en-US" sz="1600" b="1" dirty="0">
@@ -22129,7 +22129,7 @@
                 <a:ea typeface="Consolas" pitchFamily="34" charset="-122"/>
                 <a:cs typeface="Consolas" pitchFamily="34" charset="-120"/>
               </a:rPr>
-              <a:t xml:space="preserve">      </a:t>
+              <a:t>      </a:t>
             </a:r>
             <a:r>
               <a:rPr lang="en-US" sz="1600" b="1" dirty="0">
@@ -22176,7 +22176,7 @@
                 <a:ea typeface="Consolas" pitchFamily="34" charset="-122"/>
                 <a:cs typeface="Consolas" pitchFamily="34" charset="-120"/>
               </a:rPr>
-              <a:t xml:space="preserve">        </a:t>
+              <a:t>        </a:t>
             </a:r>
             <a:r>
               <a:rPr lang="en-US" sz="1600" b="1" dirty="0">
@@ -22223,7 +22223,7 @@
                 <a:ea typeface="Consolas" pitchFamily="34" charset="-122"/>
                 <a:cs typeface="Consolas" pitchFamily="34" charset="-120"/>
               </a:rPr>
-              <a:t xml:space="preserve">      }</a:t>
+              <a:t>      }</a:t>
             </a:r>
             <a:endParaRPr lang="en-US" sz="1600" b="1" dirty="0"/>
           </a:p>
@@ -22262,7 +22262,7 @@
                 <a:ea typeface="Consolas" pitchFamily="34" charset="-122"/>
                 <a:cs typeface="Consolas" pitchFamily="34" charset="-120"/>
               </a:rPr>
-              <a:t xml:space="preserve">    }</a:t>
+              <a:t>    }</a:t>
             </a:r>
             <a:endParaRPr lang="en-US" sz="1600" b="1" dirty="0"/>
           </a:p>
@@ -22301,7 +22301,7 @@
                 <a:ea typeface="Consolas" pitchFamily="34" charset="-122"/>
                 <a:cs typeface="Consolas" pitchFamily="34" charset="-120"/>
               </a:rPr>
-              <a:t xml:space="preserve">  }</a:t>
+              <a:t>  }</a:t>
             </a:r>
             <a:endParaRPr lang="en-US" sz="1600" b="1" dirty="0"/>
           </a:p>
@@ -23075,7 +23075,7 @@
                 <a:latin typeface="Times New Roman" panose="02020603050405020304" pitchFamily="18" charset="0"/>
                 <a:cs typeface="Times New Roman" panose="02020603050405020304" pitchFamily="18" charset="0"/>
               </a:rPr>
-              <a:t xml:space="preserve"> </a:t>
+              <a:t> </a:t>
             </a:r>
             <a:r>
               <a:rPr lang="en-US" sz="1400" b="1" dirty="0" err="1">
@@ -23089,7 +23089,7 @@
                 <a:latin typeface="Times New Roman" panose="02020603050405020304" pitchFamily="18" charset="0"/>
                 <a:cs typeface="Times New Roman" panose="02020603050405020304" pitchFamily="18" charset="0"/>
               </a:rPr>
-              <a:t xml:space="preserve"> — </a:t>
+              <a:t> — </a:t>
             </a:r>
             <a:r>
               <a:rPr lang="en-US" sz="1400" b="1" dirty="0" err="1">
@@ -23103,7 +23103,7 @@
                 <a:latin typeface="Times New Roman" panose="02020603050405020304" pitchFamily="18" charset="0"/>
                 <a:cs typeface="Times New Roman" panose="02020603050405020304" pitchFamily="18" charset="0"/>
               </a:rPr>
-              <a:t xml:space="preserve"> </a:t>
+              <a:t> </a:t>
             </a:r>
             <a:r>
               <a:rPr lang="en-US" sz="1400" b="1" dirty="0" err="1">
@@ -23250,7 +23250,7 @@
                   <a:srgbClr val="FF0000"/>
                 </a:solidFill>
               </a:rPr>
-              <a:t xml:space="preserve">VI. </a:t>
+              <a:t>VI. </a:t>
             </a:r>
             <a:r>
               <a:rPr lang="fr-CA" sz="2400" cap="none" dirty="0" err="1" smtClean="0">
@@ -23266,7 +23266,7 @@
                   <a:srgbClr val="FF0000"/>
                 </a:solidFill>
               </a:rPr>
-              <a:t xml:space="preserve"> Class</a:t>
+              <a:t> Class</a:t>
             </a:r>
             <a:endParaRPr lang="fr-CA" sz="2400" cap="none" dirty="0">
               <a:solidFill>
@@ -23439,7 +23439,7 @@
                 <a:ea typeface="Calibri" pitchFamily="34" charset="-122"/>
                 <a:cs typeface="Times New Roman" panose="02020603050405020304" pitchFamily="18" charset="0"/>
               </a:rPr>
-              <a:t xml:space="preserve">Une classe sans nom déclarée et instanciée </a:t>
+              <a:t>Une classe sans nom déclarée et instanciée </a:t>
             </a:r>
             <a:r>
               <a:rPr lang="en-US" sz="1600" dirty="0" err="1">
@@ -23461,7 +23461,7 @@
                 <a:ea typeface="Calibri" pitchFamily="34" charset="-122"/>
                 <a:cs typeface="Times New Roman" panose="02020603050405020304" pitchFamily="18" charset="0"/>
               </a:rPr>
-              <a:t xml:space="preserve"> une seule expression.</a:t>
+              <a:t> une seule expression.</a:t>
             </a:r>
             <a:endParaRPr lang="en-US" sz="1600" dirty="0">
               <a:latin typeface="Times New Roman" panose="02020603050405020304" pitchFamily="18" charset="0"/>
@@ -23880,7 +23880,7 @@
                 <a:ea typeface="Consolas" pitchFamily="34" charset="-122"/>
                 <a:cs typeface="Consolas" pitchFamily="34" charset="-120"/>
               </a:rPr>
-              <a:t xml:space="preserve">  </a:t>
+              <a:t>  </a:t>
             </a:r>
             <a:r>
               <a:rPr lang="en-US" sz="1400" dirty="0">
@@ -23927,7 +23927,7 @@
                 <a:ea typeface="Consolas" pitchFamily="34" charset="-122"/>
                 <a:cs typeface="Consolas" pitchFamily="34" charset="-120"/>
               </a:rPr>
-              <a:t xml:space="preserve">  Interface()</a:t>
+              <a:t>  Interface()</a:t>
             </a:r>
             <a:endParaRPr lang="en-US" sz="1400" dirty="0"/>
           </a:p>
@@ -23966,7 +23966,7 @@
                 <a:ea typeface="Consolas" pitchFamily="34" charset="-122"/>
                 <a:cs typeface="Consolas" pitchFamily="34" charset="-120"/>
               </a:rPr>
-              <a:t xml:space="preserve">  {</a:t>
+              <a:t>  {</a:t>
             </a:r>
             <a:endParaRPr lang="en-US" sz="1400" dirty="0"/>
           </a:p>
@@ -24005,7 +24005,7 @@
                 <a:ea typeface="Consolas" pitchFamily="34" charset="-122"/>
                 <a:cs typeface="Consolas" pitchFamily="34" charset="-120"/>
               </a:rPr>
-              <a:t xml:space="preserve">    @Override</a:t>
+              <a:t>    @Override</a:t>
             </a:r>
             <a:endParaRPr lang="en-US" sz="1400" dirty="0"/>
           </a:p>
@@ -24044,7 +24044,7 @@
                 <a:ea typeface="Consolas" pitchFamily="34" charset="-122"/>
                 <a:cs typeface="Consolas" pitchFamily="34" charset="-120"/>
               </a:rPr>
-              <a:t xml:space="preserve">    public void</a:t>
+              <a:t>    public void</a:t>
             </a:r>
             <a:endParaRPr lang="en-US" sz="1400" dirty="0"/>
           </a:p>
@@ -24083,7 +24083,7 @@
                 <a:ea typeface="Consolas" pitchFamily="34" charset="-122"/>
                 <a:cs typeface="Consolas" pitchFamily="34" charset="-120"/>
               </a:rPr>
-              <a:t xml:space="preserve">    </a:t>
+              <a:t>    </a:t>
             </a:r>
             <a:r>
               <a:rPr lang="en-US" sz="1400" b="1" dirty="0">
@@ -24130,7 +24130,7 @@
                 <a:ea typeface="Consolas" pitchFamily="34" charset="-122"/>
                 <a:cs typeface="Consolas" pitchFamily="34" charset="-120"/>
               </a:rPr>
-              <a:t xml:space="preserve">      // Code</a:t>
+              <a:t>      // Code</a:t>
             </a:r>
             <a:endParaRPr lang="en-US" sz="1400" dirty="0"/>
           </a:p>
@@ -24169,7 +24169,7 @@
                 <a:ea typeface="Consolas" pitchFamily="34" charset="-122"/>
                 <a:cs typeface="Consolas" pitchFamily="34" charset="-120"/>
               </a:rPr>
-              <a:t xml:space="preserve">    }</a:t>
+              <a:t>    }</a:t>
             </a:r>
             <a:endParaRPr lang="en-US" sz="1400" dirty="0"/>
           </a:p>
@@ -24208,7 +24208,7 @@
                 <a:ea typeface="Consolas" pitchFamily="34" charset="-122"/>
                 <a:cs typeface="Consolas" pitchFamily="34" charset="-120"/>
               </a:rPr>
-              <a:t xml:space="preserve">  };</a:t>
+              <a:t>  };</a:t>
             </a:r>
             <a:endParaRPr lang="en-US" sz="1400" dirty="0"/>
           </a:p>
@@ -24410,7 +24410,7 @@
             </a:pPr>
             <a:r>
               <a:rPr lang="fr-CA" b="1" dirty="0" smtClean="0"/>
-              <a:t xml:space="preserve"> INTRODUCTION</a:t>
+              <a:t> INTRODUCTION</a:t>
             </a:r>
           </a:p>
           <a:p>
@@ -24422,7 +24422,7 @@
             </a:pPr>
             <a:r>
               <a:rPr lang="fr-CA" b="1" dirty="0" smtClean="0"/>
-              <a:t xml:space="preserve"> GÉNÉRIQUE (SYNTAXE DE BASE)</a:t>
+              <a:t> GÉNÉRIQUE (SYNTAXE DE BASE)</a:t>
             </a:r>
           </a:p>
           <a:p>
@@ -24434,7 +24434,7 @@
             </a:pPr>
             <a:r>
               <a:rPr lang="fr-CA" b="1" dirty="0" smtClean="0"/>
-              <a:t xml:space="preserve"> COLLECTION</a:t>
+              <a:t> COLLECTION</a:t>
             </a:r>
           </a:p>
           <a:p>
@@ -24446,7 +24446,7 @@
             </a:pPr>
             <a:r>
               <a:rPr lang="en-US" b="1" dirty="0" smtClean="0"/>
-              <a:t xml:space="preserve"> </a:t>
+              <a:t> </a:t>
             </a:r>
             <a:r>
               <a:rPr lang="el-GR" b="1" dirty="0"/>
@@ -24454,7 +24454,7 @@
             </a:r>
             <a:r>
               <a:rPr lang="el-GR" b="1" dirty="0" smtClean="0"/>
-              <a:t xml:space="preserve">  </a:t>
+              <a:t>  </a:t>
             </a:r>
             <a:r>
               <a:rPr lang="fr-CA" b="1" dirty="0" smtClean="0"/>
@@ -24470,7 +24470,7 @@
             </a:pPr>
             <a:r>
               <a:rPr lang="fr-CA" b="1" dirty="0" smtClean="0"/>
-              <a:t xml:space="preserve"> INNER CLASSE (CLASSE INTERNE) </a:t>
+              <a:t> INNER CLASSE (CLASSE INTERNE) </a:t>
             </a:r>
           </a:p>
           <a:p>
@@ -24482,7 +24482,7 @@
             </a:pPr>
             <a:r>
               <a:rPr lang="fr-CA" b="1" dirty="0" smtClean="0"/>
-              <a:t xml:space="preserve"> ANONYMOUS CLASS </a:t>
+              <a:t> ANONYMOUS CLASS </a:t>
             </a:r>
           </a:p>
           <a:p>
@@ -24494,7 +24494,7 @@
             </a:pPr>
             <a:r>
               <a:rPr lang="fr-CA" b="1" dirty="0" smtClean="0"/>
-              <a:t xml:space="preserve"> CONCLUSION</a:t>
+              <a:t> CONCLUSION</a:t>
             </a:r>
           </a:p>
           <a:p>
@@ -24646,7 +24646,7 @@
                   <a:srgbClr val="FF0000"/>
                 </a:solidFill>
               </a:rPr>
-              <a:t xml:space="preserve">VI. </a:t>
+              <a:t>VI. </a:t>
             </a:r>
             <a:r>
               <a:rPr lang="fr-CA" sz="2400" cap="none" dirty="0" err="1">
@@ -24662,7 +24662,7 @@
                   <a:srgbClr val="FF0000"/>
                 </a:solidFill>
               </a:rPr>
-              <a:t xml:space="preserve"> Class</a:t>
+              <a:t> Class</a:t>
             </a:r>
           </a:p>
         </p:txBody>
@@ -24879,7 +24879,7 @@
                 <a:ea typeface="Consolas" pitchFamily="34" charset="-122"/>
                 <a:cs typeface="Times New Roman" panose="02020603050405020304" pitchFamily="18" charset="0"/>
               </a:rPr>
-              <a:t xml:space="preserve">    </a:t>
+              <a:t>    </a:t>
             </a:r>
             <a:r>
               <a:rPr lang="en-US" b="1" dirty="0">
@@ -24999,7 +24999,7 @@
                 <a:ea typeface="Consolas" pitchFamily="34" charset="-122"/>
                 <a:cs typeface="Times New Roman" panose="02020603050405020304" pitchFamily="18" charset="0"/>
               </a:rPr>
-              <a:t xml:space="preserve">  </a:t>
+              <a:t>  </a:t>
             </a:r>
             <a:r>
               <a:rPr lang="en-US" b="1" dirty="0">
@@ -25086,7 +25086,7 @@
                 <a:ea typeface="Consolas" pitchFamily="34" charset="-122"/>
                 <a:cs typeface="Times New Roman" panose="02020603050405020304" pitchFamily="18" charset="0"/>
               </a:rPr>
-              <a:t xml:space="preserve">    @Override</a:t>
+              <a:t>    @Override</a:t>
             </a:r>
             <a:endParaRPr lang="en-US" dirty="0">
               <a:latin typeface="Times New Roman" panose="02020603050405020304" pitchFamily="18" charset="0"/>
@@ -25128,7 +25128,7 @@
                 <a:ea typeface="Consolas" pitchFamily="34" charset="-122"/>
                 <a:cs typeface="Times New Roman" panose="02020603050405020304" pitchFamily="18" charset="0"/>
               </a:rPr>
-              <a:t xml:space="preserve">    public void onClick(</a:t>
+              <a:t>    public void onClick(</a:t>
             </a:r>
             <a:endParaRPr lang="en-US" dirty="0">
               <a:latin typeface="Times New Roman" panose="02020603050405020304" pitchFamily="18" charset="0"/>
@@ -25170,7 +25170,7 @@
                 <a:ea typeface="Consolas" pitchFamily="34" charset="-122"/>
                 <a:cs typeface="Times New Roman" panose="02020603050405020304" pitchFamily="18" charset="0"/>
               </a:rPr>
-              <a:t xml:space="preserve">        </a:t>
+              <a:t>        </a:t>
             </a:r>
             <a:r>
               <a:rPr lang="en-US" b="1" dirty="0">
@@ -25226,7 +25226,7 @@
                 <a:ea typeface="Consolas" pitchFamily="34" charset="-122"/>
                 <a:cs typeface="Times New Roman" panose="02020603050405020304" pitchFamily="18" charset="0"/>
               </a:rPr>
-              <a:t xml:space="preserve">      Toast.makeText(ctx,</a:t>
+              <a:t>      Toast.makeText(ctx,</a:t>
             </a:r>
             <a:endParaRPr lang="en-US" b="1" dirty="0">
               <a:solidFill>
@@ -25271,7 +25271,7 @@
                 <a:ea typeface="Consolas" pitchFamily="34" charset="-122"/>
                 <a:cs typeface="Times New Roman" panose="02020603050405020304" pitchFamily="18" charset="0"/>
               </a:rPr>
-              <a:t xml:space="preserve">        "Bouton cliqué !",</a:t>
+              <a:t>        "Bouton cliqué !",</a:t>
             </a:r>
             <a:endParaRPr lang="en-US" dirty="0">
               <a:latin typeface="Times New Roman" panose="02020603050405020304" pitchFamily="18" charset="0"/>
@@ -25313,7 +25313,7 @@
                 <a:ea typeface="Consolas" pitchFamily="34" charset="-122"/>
                 <a:cs typeface="Times New Roman" panose="02020603050405020304" pitchFamily="18" charset="0"/>
               </a:rPr>
-              <a:t xml:space="preserve">        Toast.LENGTH_SHORT)</a:t>
+              <a:t>        Toast.LENGTH_SHORT)</a:t>
             </a:r>
             <a:endParaRPr lang="en-US" dirty="0">
               <a:latin typeface="Times New Roman" panose="02020603050405020304" pitchFamily="18" charset="0"/>
@@ -25355,7 +25355,7 @@
                 <a:ea typeface="Consolas" pitchFamily="34" charset="-122"/>
                 <a:cs typeface="Times New Roman" panose="02020603050405020304" pitchFamily="18" charset="0"/>
               </a:rPr>
-              <a:t xml:space="preserve">        </a:t>
+              <a:t>        </a:t>
             </a:r>
             <a:r>
               <a:rPr lang="en-US" b="1" dirty="0">
@@ -25405,7 +25405,7 @@
                 <a:ea typeface="Consolas" pitchFamily="34" charset="-122"/>
                 <a:cs typeface="Times New Roman" panose="02020603050405020304" pitchFamily="18" charset="0"/>
               </a:rPr>
-              <a:t xml:space="preserve">    }</a:t>
+              <a:t>    }</a:t>
             </a:r>
             <a:endParaRPr lang="en-US" dirty="0">
               <a:latin typeface="Times New Roman" panose="02020603050405020304" pitchFamily="18" charset="0"/>
@@ -25447,7 +25447,7 @@
                 <a:ea typeface="Consolas" pitchFamily="34" charset="-122"/>
                 <a:cs typeface="Times New Roman" panose="02020603050405020304" pitchFamily="18" charset="0"/>
               </a:rPr>
-              <a:t xml:space="preserve">  }</a:t>
+              <a:t>  }</a:t>
             </a:r>
             <a:endParaRPr lang="en-US" dirty="0">
               <a:latin typeface="Times New Roman" panose="02020603050405020304" pitchFamily="18" charset="0"/>
@@ -26228,12 +26228,12 @@
           <a:lstStyle/>
           <a:p>
             <a:r>
-              <a:rPr lang="fr-CA" sz="2400" cap="none" dirty="0" smtClean="0">
+              <a:rPr lang="fr-CA" sz="2400" cap="none" smtClean="0">
                 <a:solidFill>
                   <a:srgbClr val="FF0000"/>
                 </a:solidFill>
               </a:rPr>
-              <a:t xml:space="preserve">VII. </a:t>
+              <a:t>VII. </a:t>
             </a:r>
             <a:r>
               <a:rPr lang="fr-CA" sz="2400" cap="none" dirty="0" smtClean="0">
@@ -26259,8 +26259,8 @@
         </p:nvSpPr>
         <p:spPr>
           <a:xfrm>
-            <a:off x="715424" y="800000"/>
-            <a:ext cx="8580000" cy="360000"/>
+            <a:off x="731218" y="1345844"/>
+            <a:ext cx="8580000" cy="495000"/>
           </a:xfrm>
           <a:prstGeom prst="rect">
             <a:avLst/>
@@ -26278,13 +26278,22 @@
               <a:buNone/>
             </a:pPr>
             <a:r>
+              <a:rPr lang="fr-CA" sz="1400" b="1" i="1" dirty="0">
+                <a:solidFill>
+                  <a:srgbClr val="475569"/>
+                </a:solidFill>
+                <a:latin typeface="Times New Roman" panose="02020603050405020304" pitchFamily="18" charset="0"/>
+              </a:rPr>
+              <a:t>Les Génériques et Collections forment un écosystème cohérent qui rend le code Java plus sûr, plus lisible et plus puissant</a:t>
+            </a:r>
+            <a:r>
               <a:rPr lang="fr-CA" sz="1300" i="1" dirty="0">
                 <a:solidFill>
                   <a:srgbClr val="475569"/>
                 </a:solidFill>
                 <a:latin typeface="Times New Roman" panose="02020603050405020304" pitchFamily="18" charset="0"/>
               </a:rPr>
-              <a:t>Les Génériques et Collections forment un écosystème cohérent qui rend le code Java plus sûr, plus lisible et plus puissant.</a:t>
+              <a:t>.</a:t>
             </a:r>
           </a:p>
         </p:txBody>
@@ -26297,7 +26306,7 @@
         </p:nvSpPr>
         <p:spPr>
           <a:xfrm>
-            <a:off x="715424" y="1240000"/>
+            <a:off x="702079" y="2437072"/>
             <a:ext cx="2680000" cy="1480000"/>
           </a:xfrm>
           <a:prstGeom prst="rect">
@@ -26321,7 +26330,7 @@
         </p:nvSpPr>
         <p:spPr>
           <a:xfrm>
-            <a:off x="715424" y="1240000"/>
+            <a:off x="702079" y="2437072"/>
             <a:ext cx="2680000" cy="55000"/>
           </a:xfrm>
           <a:prstGeom prst="rect">
@@ -26343,7 +26352,7 @@
         </p:nvSpPr>
         <p:spPr>
           <a:xfrm>
-            <a:off x="800000" y="1340000"/>
+            <a:off x="786655" y="2537072"/>
             <a:ext cx="2510000" cy="1320000"/>
           </a:xfrm>
           <a:prstGeom prst="rect">
@@ -26395,7 +26404,7 @@
         </p:nvSpPr>
         <p:spPr>
           <a:xfrm>
-            <a:off x="3527500" y="1240000"/>
+            <a:off x="3514155" y="2437072"/>
             <a:ext cx="2680000" cy="1480000"/>
           </a:xfrm>
           <a:prstGeom prst="rect">
@@ -26419,7 +26428,7 @@
         </p:nvSpPr>
         <p:spPr>
           <a:xfrm>
-            <a:off x="3527500" y="1240000"/>
+            <a:off x="3514155" y="2437072"/>
             <a:ext cx="2680000" cy="55000"/>
           </a:xfrm>
           <a:prstGeom prst="rect">
@@ -26441,7 +26450,7 @@
         </p:nvSpPr>
         <p:spPr>
           <a:xfrm>
-            <a:off x="3612500" y="1340000"/>
+            <a:off x="3599155" y="2537072"/>
             <a:ext cx="2510000" cy="1320000"/>
           </a:xfrm>
           <a:prstGeom prst="rect">
@@ -26493,7 +26502,7 @@
         </p:nvSpPr>
         <p:spPr>
           <a:xfrm>
-            <a:off x="6340000" y="1240000"/>
+            <a:off x="6326655" y="2437072"/>
             <a:ext cx="2680000" cy="1480000"/>
           </a:xfrm>
           <a:prstGeom prst="rect">
@@ -26517,7 +26526,7 @@
         </p:nvSpPr>
         <p:spPr>
           <a:xfrm>
-            <a:off x="6340000" y="1240000"/>
+            <a:off x="6326655" y="2437072"/>
             <a:ext cx="2680000" cy="55000"/>
           </a:xfrm>
           <a:prstGeom prst="rect">
@@ -26539,7 +26548,7 @@
         </p:nvSpPr>
         <p:spPr>
           <a:xfrm>
-            <a:off x="6425000" y="1340000"/>
+            <a:off x="6411655" y="2537072"/>
             <a:ext cx="2510000" cy="1320000"/>
           </a:xfrm>
           <a:prstGeom prst="rect">
@@ -26591,7 +26600,7 @@
         </p:nvSpPr>
         <p:spPr>
           <a:xfrm>
-            <a:off x="715424" y="2880000"/>
+            <a:off x="702079" y="4077072"/>
             <a:ext cx="2680000" cy="1480000"/>
           </a:xfrm>
           <a:prstGeom prst="rect">
@@ -26615,7 +26624,7 @@
         </p:nvSpPr>
         <p:spPr>
           <a:xfrm>
-            <a:off x="715424" y="2880000"/>
+            <a:off x="702079" y="4077072"/>
             <a:ext cx="2680000" cy="55000"/>
           </a:xfrm>
           <a:prstGeom prst="rect">
@@ -26637,7 +26646,7 @@
         </p:nvSpPr>
         <p:spPr>
           <a:xfrm>
-            <a:off x="800000" y="2980000"/>
+            <a:off x="786655" y="4177072"/>
             <a:ext cx="2510000" cy="1320000"/>
           </a:xfrm>
           <a:prstGeom prst="rect">
@@ -26689,7 +26698,7 @@
         </p:nvSpPr>
         <p:spPr>
           <a:xfrm>
-            <a:off x="3527500" y="2880000"/>
+            <a:off x="3514155" y="4077072"/>
             <a:ext cx="2680000" cy="1480000"/>
           </a:xfrm>
           <a:prstGeom prst="rect">
@@ -26713,7 +26722,7 @@
         </p:nvSpPr>
         <p:spPr>
           <a:xfrm>
-            <a:off x="3527500" y="2880000"/>
+            <a:off x="3514155" y="4077072"/>
             <a:ext cx="2680000" cy="55000"/>
           </a:xfrm>
           <a:prstGeom prst="rect">
@@ -26735,7 +26744,7 @@
         </p:nvSpPr>
         <p:spPr>
           <a:xfrm>
-            <a:off x="3612500" y="2980000"/>
+            <a:off x="3599155" y="4177072"/>
             <a:ext cx="2510000" cy="1320000"/>
           </a:xfrm>
           <a:prstGeom prst="rect">
@@ -26775,89 +26784,6 @@
                 <a:latin typeface="Times New Roman" panose="02020603050405020304" pitchFamily="18" charset="0"/>
               </a:rPr>
               <a:t>Encapsulation forte, accès privilégié aux membres. Les classes anonymes ont évolué vers les lambdas.</a:t>
-            </a:r>
-          </a:p>
-        </p:txBody>
-      </p:sp>
-      <p:sp>
-        <p:nvSpPr>
-          <p:cNvPr id="56" name="SyntheseBg"/>
-          <p:cNvSpPr/>
-          <p:nvPr/>
-        </p:nvSpPr>
-        <p:spPr>
-          <a:xfrm>
-            <a:off x="715424" y="4520000"/>
-            <a:ext cx="8350000" cy="1380000"/>
-          </a:xfrm>
-          <a:prstGeom prst="rect">
-            <a:avLst/>
-          </a:prstGeom>
-          <a:solidFill>
-            <a:srgbClr val="1E293B"/>
-          </a:solidFill>
-          <a:ln>
-            <a:noFill/>
-          </a:ln>
-        </p:spPr>
-      </p:sp>
-      <p:sp>
-        <p:nvSpPr>
-          <p:cNvPr id="57" name="SyntheseText"/>
-          <p:cNvSpPr/>
-          <p:nvPr/>
-        </p:nvSpPr>
-        <p:spPr>
-          <a:xfrm>
-            <a:off x="900000" y="4570000"/>
-            <a:ext cx="7980000" cy="1280000"/>
-          </a:xfrm>
-          <a:prstGeom prst="rect">
-            <a:avLst/>
-          </a:prstGeom>
-          <a:noFill/>
-          <a:ln>
-            <a:noFill/>
-          </a:ln>
-        </p:spPr>
-        <p:txBody>
-          <a:bodyPr wrap="square" lIns="0" tIns="0" rIns="0" bIns="0" rtlCol="0" anchor="ctr"/>
-          <a:lstStyle/>
-          <a:p>
-            <a:pPr algn="ctr" marL="0" indent="0">
-              <a:buNone/>
-            </a:pPr>
-            <a:r>
-              <a:rPr lang="fr-CA" sz="1300" b="1" dirty="0">
-                <a:solidFill>
-                  <a:srgbClr val="86EFAC"/>
-                </a:solidFill>
-                <a:latin typeface="Times New Roman" panose="02020603050405020304" pitchFamily="18" charset="0"/>
-              </a:rPr>
-              <a:t xml:space="preserve">💡  En résumé : </a:t>
-            </a:r>
-            <a:r>
-              <a:rPr lang="fr-CA" sz="1300" dirty="0">
-                <a:solidFill>
-                  <a:srgbClr val="CBD5E1"/>
-                </a:solidFill>
-                <a:latin typeface="Times New Roman" panose="02020603050405020304" pitchFamily="18" charset="0"/>
-              </a:rPr>
-              <a:t>Génériques → sécurisent les types  |  Collections → organisent les données  |  Lambdas &amp; Streams → traitent élégamment  |  Classes internes → structurent la logique</a:t>
-            </a:r>
-          </a:p>
-          <a:p>
-            <a:pPr algn="ctr" marL="0" indent="0">
-              <a:buNone/>
-            </a:pPr>
-            <a:r>
-              <a:rPr lang="fr-CA" sz="1200" dirty="0">
-                <a:solidFill>
-                  <a:srgbClr val="94A3B8"/>
-                </a:solidFill>
-                <a:latin typeface="Times New Roman" panose="02020603050405020304" pitchFamily="18" charset="0"/>
-              </a:rPr>
-              <a:t>Ensemble, ces concepts forment la base du Java moderne utilisé en entreprise.</a:t>
             </a:r>
           </a:p>
         </p:txBody>
@@ -27028,7 +26954,7 @@
                   </a:outerShdw>
                 </a:effectLst>
               </a:rPr>
-              <a:t xml:space="preserve"> </a:t>
+              <a:t> </a:t>
             </a:r>
           </a:p>
         </p:txBody>
@@ -27444,7 +27370,15 @@
                   <a:srgbClr val="FF0000"/>
                 </a:solidFill>
               </a:rPr>
-              <a:t>I. INTRODUCTION</a:t>
+              <a:t>I. </a:t>
+            </a:r>
+            <a:r>
+              <a:rPr lang="fr-CA" sz="2400" cap="none" dirty="0" smtClean="0">
+                <a:solidFill>
+                  <a:srgbClr val="FF0000"/>
+                </a:solidFill>
+              </a:rPr>
+              <a:t>INTRODUCTION</a:t>
             </a:r>
             <a:endParaRPr lang="fr-CA" sz="2400" cap="none" dirty="0">
               <a:solidFill>
@@ -27569,7 +27503,7 @@
                 <a:latin typeface="Times New Roman" panose="02020603050405020304" pitchFamily="18" charset="0"/>
                 <a:cs typeface="Times New Roman" panose="02020603050405020304" pitchFamily="18" charset="0"/>
               </a:rPr>
-              <a:t xml:space="preserve"> : </a:t>
+              <a:t> : </a:t>
             </a:r>
             <a:r>
               <a:rPr lang="en-US" altLang="en-US" dirty="0" err="1">
@@ -27589,7 +27523,7 @@
                 <a:latin typeface="Times New Roman" panose="02020603050405020304" pitchFamily="18" charset="0"/>
                 <a:cs typeface="Times New Roman" panose="02020603050405020304" pitchFamily="18" charset="0"/>
               </a:rPr>
-              <a:t xml:space="preserve"> </a:t>
+              <a:t> </a:t>
             </a:r>
             <a:r>
               <a:rPr lang="en-US" altLang="en-US" dirty="0" err="1">
@@ -27649,7 +27583,7 @@
                 <a:latin typeface="Times New Roman" panose="02020603050405020304" pitchFamily="18" charset="0"/>
                 <a:cs typeface="Times New Roman" panose="02020603050405020304" pitchFamily="18" charset="0"/>
               </a:rPr>
-              <a:t xml:space="preserve">. </a:t>
+              <a:t>. </a:t>
             </a:r>
             <a:r>
               <a:rPr lang="en-US" altLang="en-US" dirty="0" err="1">
@@ -27669,7 +27603,7 @@
                 <a:latin typeface="Times New Roman" panose="02020603050405020304" pitchFamily="18" charset="0"/>
                 <a:cs typeface="Times New Roman" panose="02020603050405020304" pitchFamily="18" charset="0"/>
               </a:rPr>
-              <a:t xml:space="preserve"> à </a:t>
+              <a:t> à </a:t>
             </a:r>
             <a:r>
               <a:rPr lang="en-US" altLang="en-US" dirty="0" err="1">
@@ -27689,7 +27623,7 @@
                 <a:latin typeface="Times New Roman" panose="02020603050405020304" pitchFamily="18" charset="0"/>
                 <a:cs typeface="Times New Roman" panose="02020603050405020304" pitchFamily="18" charset="0"/>
               </a:rPr>
-              <a:t xml:space="preserve"> moment-</a:t>
+              <a:t> moment-</a:t>
             </a:r>
             <a:r>
               <a:rPr lang="en-US" altLang="en-US" dirty="0" err="1">
@@ -27709,7 +27643,7 @@
                 <a:latin typeface="Times New Roman" panose="02020603050405020304" pitchFamily="18" charset="0"/>
                 <a:cs typeface="Times New Roman" panose="02020603050405020304" pitchFamily="18" charset="0"/>
               </a:rPr>
-              <a:t xml:space="preserve"> </a:t>
+              <a:t> </a:t>
             </a:r>
             <a:r>
               <a:rPr lang="en-US" altLang="en-US" dirty="0" err="1">
@@ -27729,7 +27663,7 @@
                 <a:latin typeface="Times New Roman" panose="02020603050405020304" pitchFamily="18" charset="0"/>
                 <a:cs typeface="Times New Roman" panose="02020603050405020304" pitchFamily="18" charset="0"/>
               </a:rPr>
-              <a:t xml:space="preserve"> les interfaces List, Set, Map et les classes </a:t>
+              <a:t> les interfaces List, Set, Map et les classes </a:t>
             </a:r>
             <a:r>
               <a:rPr lang="en-US" altLang="en-US" dirty="0" err="1">
@@ -27832,7 +27766,7 @@
                 <a:latin typeface="Times New Roman" panose="02020603050405020304" pitchFamily="18" charset="0"/>
                 <a:cs typeface="Times New Roman" panose="02020603050405020304" pitchFamily="18" charset="0"/>
               </a:rPr>
-              <a:t xml:space="preserve">Les </a:t>
+              <a:t>Les </a:t>
             </a:r>
             <a:r>
               <a:rPr lang="en-US" altLang="en-US" b="1" dirty="0">
@@ -27852,7 +27786,7 @@
                 <a:latin typeface="Times New Roman" panose="02020603050405020304" pitchFamily="18" charset="0"/>
                 <a:cs typeface="Times New Roman" panose="02020603050405020304" pitchFamily="18" charset="0"/>
               </a:rPr>
-              <a:t xml:space="preserve"> : </a:t>
+              <a:t> : </a:t>
             </a:r>
             <a:r>
               <a:rPr lang="en-US" altLang="en-US" dirty="0" err="1">
@@ -27872,7 +27806,7 @@
                 <a:latin typeface="Times New Roman" panose="02020603050405020304" pitchFamily="18" charset="0"/>
                 <a:cs typeface="Times New Roman" panose="02020603050405020304" pitchFamily="18" charset="0"/>
               </a:rPr>
-              <a:t xml:space="preserve"> </a:t>
+              <a:t> </a:t>
             </a:r>
             <a:r>
               <a:rPr lang="en-US" altLang="en-US" dirty="0" err="1">
@@ -27932,7 +27866,7 @@
                 <a:latin typeface="Times New Roman" panose="02020603050405020304" pitchFamily="18" charset="0"/>
                 <a:cs typeface="Times New Roman" panose="02020603050405020304" pitchFamily="18" charset="0"/>
               </a:rPr>
-              <a:t xml:space="preserve">. Avant </a:t>
+              <a:t>. Avant </a:t>
             </a:r>
             <a:r>
               <a:rPr lang="en-US" altLang="en-US" dirty="0" err="1">
@@ -27952,7 +27886,7 @@
                 <a:latin typeface="Times New Roman" panose="02020603050405020304" pitchFamily="18" charset="0"/>
                 <a:cs typeface="Times New Roman" panose="02020603050405020304" pitchFamily="18" charset="0"/>
               </a:rPr>
-              <a:t xml:space="preserve"> date, on </a:t>
+              <a:t> date, on </a:t>
             </a:r>
             <a:r>
               <a:rPr lang="en-US" altLang="en-US" dirty="0" err="1">
@@ -27972,7 +27906,7 @@
                 <a:latin typeface="Times New Roman" panose="02020603050405020304" pitchFamily="18" charset="0"/>
                 <a:cs typeface="Times New Roman" panose="02020603050405020304" pitchFamily="18" charset="0"/>
               </a:rPr>
-              <a:t xml:space="preserve"> </a:t>
+              <a:t> </a:t>
             </a:r>
             <a:r>
               <a:rPr lang="en-US" altLang="en-US" dirty="0" err="1">
@@ -27992,7 +27926,7 @@
                 <a:latin typeface="Times New Roman" panose="02020603050405020304" pitchFamily="18" charset="0"/>
                 <a:cs typeface="Times New Roman" panose="02020603050405020304" pitchFamily="18" charset="0"/>
               </a:rPr>
-              <a:t xml:space="preserve"> </a:t>
+              <a:t> </a:t>
             </a:r>
             <a:r>
               <a:rPr lang="en-US" altLang="en-US" dirty="0" err="1">
@@ -28012,7 +27946,7 @@
                 <a:latin typeface="Times New Roman" panose="02020603050405020304" pitchFamily="18" charset="0"/>
                 <a:cs typeface="Times New Roman" panose="02020603050405020304" pitchFamily="18" charset="0"/>
               </a:rPr>
-              <a:t xml:space="preserve"> </a:t>
+              <a:t> </a:t>
             </a:r>
             <a:r>
               <a:rPr lang="en-US" altLang="en-US" dirty="0" err="1">
@@ -28032,7 +27966,7 @@
                 <a:latin typeface="Times New Roman" panose="02020603050405020304" pitchFamily="18" charset="0"/>
                 <a:cs typeface="Times New Roman" panose="02020603050405020304" pitchFamily="18" charset="0"/>
               </a:rPr>
-              <a:t xml:space="preserve"> objet </a:t>
+              <a:t> objet </a:t>
             </a:r>
             <a:r>
               <a:rPr lang="en-US" altLang="en-US" dirty="0" err="1">
@@ -28052,7 +27986,7 @@
                 <a:latin typeface="Times New Roman" panose="02020603050405020304" pitchFamily="18" charset="0"/>
                 <a:cs typeface="Times New Roman" panose="02020603050405020304" pitchFamily="18" charset="0"/>
               </a:rPr>
-              <a:t xml:space="preserve"> </a:t>
+              <a:t> </a:t>
             </a:r>
             <a:r>
               <a:rPr lang="en-US" altLang="en-US" dirty="0" err="1">
@@ -28072,7 +28006,7 @@
                 <a:latin typeface="Times New Roman" panose="02020603050405020304" pitchFamily="18" charset="0"/>
                 <a:cs typeface="Times New Roman" panose="02020603050405020304" pitchFamily="18" charset="0"/>
               </a:rPr>
-              <a:t xml:space="preserve"> </a:t>
+              <a:t> </a:t>
             </a:r>
             <a:r>
               <a:rPr lang="en-US" altLang="en-US" dirty="0" err="1" smtClean="0">
@@ -29171,7 +29105,15 @@
                   <a:srgbClr val="FF0000"/>
                 </a:solidFill>
               </a:rPr>
-              <a:t>I. INTRODUCTION</a:t>
+              <a:t>I. </a:t>
+            </a:r>
+            <a:r>
+              <a:rPr lang="fr-CA" sz="2400" cap="none" dirty="0" smtClean="0">
+                <a:solidFill>
+                  <a:srgbClr val="FF0000"/>
+                </a:solidFill>
+              </a:rPr>
+              <a:t>INTRODUCTION</a:t>
             </a:r>
             <a:endParaRPr lang="fr-CA" sz="2400" cap="none" dirty="0">
               <a:solidFill>
@@ -29362,7 +29304,7 @@
                 <a:ea typeface="Calibri" pitchFamily="34" charset="-122"/>
                 <a:cs typeface="Times New Roman" panose="02020603050405020304" pitchFamily="18" charset="0"/>
               </a:rPr>
-              <a:t xml:space="preserve">Les erreurs de type sont détectées avant </a:t>
+              <a:t>Les erreurs de type sont détectées avant </a:t>
             </a:r>
             <a:r>
               <a:rPr lang="en-US" sz="1400" dirty="0" smtClean="0">
@@ -29373,7 +29315,7 @@
                 <a:ea typeface="Calibri" pitchFamily="34" charset="-122"/>
                 <a:cs typeface="Times New Roman" panose="02020603050405020304" pitchFamily="18" charset="0"/>
               </a:rPr>
-              <a:t xml:space="preserve">l’exécution du </a:t>
+              <a:t>l’exécution du </a:t>
             </a:r>
             <a:r>
               <a:rPr lang="en-US" sz="1400" dirty="0">
@@ -30881,7 +30823,7 @@
                   <a:srgbClr val="FF0000"/>
                 </a:solidFill>
               </a:rPr>
-              <a:t xml:space="preserve">II. Générique (Syntaxe de base) </a:t>
+              <a:t>II. Générique (Syntaxe de base) </a:t>
             </a:r>
             <a:endParaRPr lang="fr-CA" sz="2400" cap="none" dirty="0">
               <a:solidFill>
@@ -30954,7 +30896,7 @@
                 <a:latin typeface="Times New Roman" panose="02020603050405020304" pitchFamily="18" charset="0"/>
                 <a:cs typeface="Times New Roman" panose="02020603050405020304" pitchFamily="18" charset="0"/>
               </a:rPr>
-              <a:t xml:space="preserve">En </a:t>
+              <a:t>En </a:t>
             </a:r>
             <a:r>
               <a:rPr lang="fr-FR" dirty="0">
@@ -30968,14 +30910,7 @@
                 <a:latin typeface="Times New Roman" panose="02020603050405020304" pitchFamily="18" charset="0"/>
                 <a:cs typeface="Times New Roman" panose="02020603050405020304" pitchFamily="18" charset="0"/>
               </a:rPr>
-              <a:t xml:space="preserve"> par des </a:t>
-            </a:r>
-            <a:r>
-              <a:rPr lang="en-US" dirty="0" smtClean="0">
-                <a:latin typeface="Times New Roman" panose="02020603050405020304" pitchFamily="18" charset="0"/>
-                <a:cs typeface="Times New Roman" panose="02020603050405020304" pitchFamily="18" charset="0"/>
-              </a:rPr>
-              <a:t>types.</a:t>
+              <a:t> par des types.</a:t>
             </a:r>
             <a:endParaRPr lang="en-US" dirty="0">
               <a:latin typeface="Times New Roman" panose="02020603050405020304" pitchFamily="18" charset="0"/>
@@ -32214,7 +32149,7 @@
                   <a:srgbClr val="FF0000"/>
                 </a:solidFill>
               </a:rPr>
-              <a:t xml:space="preserve">II. </a:t>
+              <a:t>II. </a:t>
             </a:r>
             <a:r>
               <a:rPr lang="fr-CA" sz="2400" cap="none" dirty="0" smtClean="0">
@@ -32222,7 +32157,7 @@
                   <a:srgbClr val="FF0000"/>
                 </a:solidFill>
               </a:rPr>
-              <a:t xml:space="preserve">Générique </a:t>
+              <a:t>Générique </a:t>
             </a:r>
             <a:r>
               <a:rPr lang="fr-CA" sz="2400" cap="none" dirty="0">
@@ -32230,7 +32165,7 @@
                   <a:srgbClr val="FF0000"/>
                 </a:solidFill>
               </a:rPr>
-              <a:t xml:space="preserve">(Syntaxe de base) </a:t>
+              <a:t>(Syntaxe de base) </a:t>
             </a:r>
           </a:p>
         </p:txBody>
@@ -32414,7 +32349,7 @@
                 <a:ea typeface="Consolas" pitchFamily="34" charset="-122"/>
                 <a:cs typeface="Times New Roman" panose="02020603050405020304" pitchFamily="18" charset="0"/>
               </a:rPr>
-              <a:t xml:space="preserve">    private T contenu;          // T est utilise comme un vrai type</a:t>
+              <a:t>    private T contenu;          // T est utilise comme un vrai type</a:t>
             </a:r>
             <a:endParaRPr lang="en-US" sz="1400" dirty="0">
               <a:latin typeface="Times New Roman" panose="02020603050405020304" pitchFamily="18" charset="0"/>
@@ -32443,7 +32378,7 @@
                 <a:ea typeface="Consolas" pitchFamily="34" charset="-122"/>
                 <a:cs typeface="Times New Roman" panose="02020603050405020304" pitchFamily="18" charset="0"/>
               </a:rPr>
-              <a:t xml:space="preserve">    public void mettre(T valeur) {</a:t>
+              <a:t>    public void mettre(T valeur) {</a:t>
             </a:r>
             <a:endParaRPr lang="en-US" sz="1400" dirty="0">
               <a:latin typeface="Times New Roman" panose="02020603050405020304" pitchFamily="18" charset="0"/>
@@ -32463,7 +32398,7 @@
                 <a:ea typeface="Consolas" pitchFamily="34" charset="-122"/>
                 <a:cs typeface="Times New Roman" panose="02020603050405020304" pitchFamily="18" charset="0"/>
               </a:rPr>
-              <a:t xml:space="preserve">        this.contenu = valeur;</a:t>
+              <a:t>        this.contenu = valeur;</a:t>
             </a:r>
             <a:endParaRPr lang="en-US" sz="1400" dirty="0">
               <a:latin typeface="Times New Roman" panose="02020603050405020304" pitchFamily="18" charset="0"/>
@@ -32483,7 +32418,7 @@
                 <a:ea typeface="Consolas" pitchFamily="34" charset="-122"/>
                 <a:cs typeface="Times New Roman" panose="02020603050405020304" pitchFamily="18" charset="0"/>
               </a:rPr>
-              <a:t xml:space="preserve">    }</a:t>
+              <a:t>    }</a:t>
             </a:r>
             <a:endParaRPr lang="en-US" sz="1400" dirty="0">
               <a:latin typeface="Times New Roman" panose="02020603050405020304" pitchFamily="18" charset="0"/>
@@ -32512,7 +32447,7 @@
                 <a:ea typeface="Consolas" pitchFamily="34" charset="-122"/>
                 <a:cs typeface="Times New Roman" panose="02020603050405020304" pitchFamily="18" charset="0"/>
               </a:rPr>
-              <a:t xml:space="preserve">    public T prendre() {</a:t>
+              <a:t>    public T prendre() {</a:t>
             </a:r>
             <a:endParaRPr lang="en-US" sz="1400" dirty="0">
               <a:latin typeface="Times New Roman" panose="02020603050405020304" pitchFamily="18" charset="0"/>
@@ -32532,7 +32467,7 @@
                 <a:ea typeface="Consolas" pitchFamily="34" charset="-122"/>
                 <a:cs typeface="Times New Roman" panose="02020603050405020304" pitchFamily="18" charset="0"/>
               </a:rPr>
-              <a:t xml:space="preserve">        return contenu;         // retourne exactement le bon type</a:t>
+              <a:t>        return contenu;         // retourne exactement le bon type</a:t>
             </a:r>
             <a:endParaRPr lang="en-US" sz="1400" dirty="0">
               <a:latin typeface="Times New Roman" panose="02020603050405020304" pitchFamily="18" charset="0"/>
@@ -32552,7 +32487,7 @@
                 <a:ea typeface="Consolas" pitchFamily="34" charset="-122"/>
                 <a:cs typeface="Times New Roman" panose="02020603050405020304" pitchFamily="18" charset="0"/>
               </a:rPr>
-              <a:t xml:space="preserve">    }</a:t>
+              <a:t>    }</a:t>
             </a:r>
             <a:endParaRPr lang="en-US" sz="1400" dirty="0">
               <a:latin typeface="Times New Roman" panose="02020603050405020304" pitchFamily="18" charset="0"/>
@@ -33706,7 +33641,7 @@
                   <a:srgbClr val="FF0000"/>
                 </a:solidFill>
               </a:rPr>
-              <a:t xml:space="preserve">II. </a:t>
+              <a:t>II. </a:t>
             </a:r>
             <a:r>
               <a:rPr lang="fr-CA" sz="2400" cap="none" dirty="0" smtClean="0">
@@ -33714,7 +33649,7 @@
                   <a:srgbClr val="FF0000"/>
                 </a:solidFill>
               </a:rPr>
-              <a:t xml:space="preserve">Générique </a:t>
+              <a:t>Générique </a:t>
             </a:r>
             <a:r>
               <a:rPr lang="fr-CA" sz="2400" cap="none" dirty="0">
@@ -33722,7 +33657,7 @@
                   <a:srgbClr val="FF0000"/>
                 </a:solidFill>
               </a:rPr>
-              <a:t xml:space="preserve">(Syntaxe de base) </a:t>
+              <a:t>(Syntaxe de base) </a:t>
             </a:r>
           </a:p>
         </p:txBody>
@@ -33807,7 +33742,7 @@
                 <a:ea typeface="Calibri" pitchFamily="34" charset="-122"/>
                 <a:cs typeface="Times New Roman" panose="02020603050405020304" pitchFamily="18" charset="0"/>
               </a:rPr>
-              <a:t xml:space="preserve"> </a:t>
+              <a:t> </a:t>
             </a:r>
             <a:r>
               <a:rPr lang="en-US" sz="1400" b="1" dirty="0" err="1" smtClean="0">
@@ -33829,7 +33764,7 @@
                 <a:ea typeface="Calibri" pitchFamily="34" charset="-122"/>
                 <a:cs typeface="Times New Roman" panose="02020603050405020304" pitchFamily="18" charset="0"/>
               </a:rPr>
-              <a:t xml:space="preserve">&lt;T&gt; </a:t>
+              <a:t>&lt;T&gt; </a:t>
             </a:r>
             <a:r>
               <a:rPr lang="en-US" sz="1400" b="1" dirty="0">
@@ -33878,7 +33813,7 @@
                 <a:latin typeface="Times New Roman" panose="02020603050405020304" pitchFamily="18" charset="0"/>
                 <a:cs typeface="Times New Roman" panose="02020603050405020304" pitchFamily="18" charset="0"/>
               </a:rPr>
-              <a:t xml:space="preserve">Le carton est toujours le même — seul le contenu change </a:t>
+              <a:t>Le carton est toujours le même — seul le contenu change </a:t>
             </a:r>
             <a:r>
               <a:rPr lang="en-US" sz="1400" dirty="0" err="1" smtClean="0">
@@ -33892,7 +33827,7 @@
                 <a:latin typeface="Times New Roman" panose="02020603050405020304" pitchFamily="18" charset="0"/>
                 <a:cs typeface="Times New Roman" panose="02020603050405020304" pitchFamily="18" charset="0"/>
               </a:rPr>
-              <a:t xml:space="preserve"> </a:t>
+              <a:t> </a:t>
             </a:r>
             <a:r>
               <a:rPr lang="en-US" sz="1400" dirty="0" err="1" smtClean="0">
@@ -33906,7 +33841,7 @@
                 <a:latin typeface="Times New Roman" panose="02020603050405020304" pitchFamily="18" charset="0"/>
                 <a:cs typeface="Times New Roman" panose="02020603050405020304" pitchFamily="18" charset="0"/>
               </a:rPr>
-              <a:t xml:space="preserve"> de </a:t>
+              <a:t> de </a:t>
             </a:r>
             <a:r>
               <a:rPr lang="en-US" sz="1400" dirty="0">
@@ -34144,7 +34079,7 @@
                 <a:ea typeface="Calibri" pitchFamily="34" charset="-122"/>
                 <a:cs typeface="Times New Roman" panose="02020603050405020304" pitchFamily="18" charset="0"/>
               </a:rPr>
-              <a:t xml:space="preserve">On sait que c'est un téléphone à l'intérieur. Pas besoin de </a:t>
+              <a:t>On sait que c'est un téléphone à l'intérieur. Pas besoin de </a:t>
             </a:r>
             <a:r>
               <a:rPr lang="en-US" sz="1400" dirty="0" smtClean="0">
@@ -34171,7 +34106,7 @@
                 <a:ea typeface="Calibri" pitchFamily="34" charset="-122"/>
                 <a:cs typeface="Times New Roman" panose="02020603050405020304" pitchFamily="18" charset="0"/>
               </a:rPr>
-              <a:t xml:space="preserve">le </a:t>
+              <a:t>le </a:t>
             </a:r>
             <a:r>
               <a:rPr lang="en-US" sz="1400" dirty="0">
@@ -34393,7 +34328,7 @@
                 <a:ea typeface="Calibri" pitchFamily="34" charset="-122"/>
                 <a:cs typeface="Times New Roman" panose="02020603050405020304" pitchFamily="18" charset="0"/>
               </a:rPr>
-              <a:t xml:space="preserve"> à pizza</a:t>
+              <a:t> à pizza</a:t>
             </a:r>
             <a:endParaRPr lang="en-US" sz="1400" dirty="0">
               <a:latin typeface="Times New Roman" panose="02020603050405020304" pitchFamily="18" charset="0"/>
@@ -34435,7 +34370,7 @@
                 <a:ea typeface="Calibri" pitchFamily="34" charset="-122"/>
                 <a:cs typeface="Times New Roman" panose="02020603050405020304" pitchFamily="18" charset="0"/>
               </a:rPr>
-              <a:t xml:space="preserve">Même boîte, autre contenu. On ne peut pas mettre un téléphone dans une boîte à </a:t>
+              <a:t>Même boîte, autre contenu. On ne peut pas mettre un téléphone dans une boîte à </a:t>
             </a:r>
             <a:r>
               <a:rPr lang="en-US" sz="1400" dirty="0" smtClean="0">
@@ -34446,7 +34381,7 @@
                 <a:ea typeface="Calibri" pitchFamily="34" charset="-122"/>
                 <a:cs typeface="Times New Roman" panose="02020603050405020304" pitchFamily="18" charset="0"/>
               </a:rPr>
-              <a:t xml:space="preserve">pizza, le </a:t>
+              <a:t>pizza, le </a:t>
             </a:r>
             <a:r>
               <a:rPr lang="en-US" sz="1400" dirty="0">
@@ -34656,7 +34591,7 @@
                 <a:ea typeface="Calibri" pitchFamily="34" charset="-122"/>
                 <a:cs typeface="Times New Roman" panose="02020603050405020304" pitchFamily="18" charset="0"/>
               </a:rPr>
-              <a:t xml:space="preserve">Sans générique, n'importe quoi pourrait entrer. Avec &lt;T&gt;, seul le bon type </a:t>
+              <a:t>Sans générique, n'importe quoi pourrait entrer. Avec &lt;T&gt;, seul le bon type </a:t>
             </a:r>
             <a:r>
               <a:rPr lang="en-US" sz="1400" dirty="0" err="1">
@@ -34678,7 +34613,7 @@
                 <a:ea typeface="Calibri" pitchFamily="34" charset="-122"/>
                 <a:cs typeface="Times New Roman" panose="02020603050405020304" pitchFamily="18" charset="0"/>
               </a:rPr>
-              <a:t xml:space="preserve"> </a:t>
+              <a:t> </a:t>
             </a:r>
             <a:r>
               <a:rPr lang="en-US" sz="1400" dirty="0" err="1" smtClean="0">
@@ -34700,7 +34635,7 @@
                 <a:ea typeface="Calibri" pitchFamily="34" charset="-122"/>
                 <a:cs typeface="Times New Roman" panose="02020603050405020304" pitchFamily="18" charset="0"/>
               </a:rPr>
-              <a:t xml:space="preserve">, </a:t>
+              <a:t>, </a:t>
             </a:r>
             <a:r>
               <a:rPr lang="en-US" sz="1400" dirty="0" err="1" smtClean="0">
@@ -34722,7 +34657,7 @@
                 <a:ea typeface="Calibri" pitchFamily="34" charset="-122"/>
                 <a:cs typeface="Times New Roman" panose="02020603050405020304" pitchFamily="18" charset="0"/>
               </a:rPr>
-              <a:t xml:space="preserve"> </a:t>
+              <a:t> </a:t>
             </a:r>
             <a:r>
               <a:rPr lang="en-US" sz="1400" dirty="0">
@@ -34843,7 +34778,7 @@
                 <a:latin typeface="Times New Roman" panose="02020603050405020304" pitchFamily="18" charset="0"/>
                 <a:cs typeface="Times New Roman" panose="02020603050405020304" pitchFamily="18" charset="0"/>
               </a:rPr>
-              <a:t xml:space="preserve">: </a:t>
+              <a:t>: </a:t>
             </a:r>
             <a:endParaRPr lang="en-US" b="1" dirty="0">
               <a:latin typeface="Times New Roman" panose="02020603050405020304" pitchFamily="18" charset="0"/>
@@ -35826,42 +35761,35 @@
                 <a:latin typeface="Times New Roman" panose="02020603050405020304" pitchFamily="18" charset="0"/>
                 <a:cs typeface="Times New Roman" panose="02020603050405020304" pitchFamily="18" charset="0"/>
               </a:rPr>
-              <a:t xml:space="preserve">Collection = </a:t>
+              <a:t>Collection =  </a:t>
+            </a:r>
+            <a:r>
+              <a:rPr lang="en-US" sz="1600" dirty="0">
+                <a:latin typeface="Times New Roman" panose="02020603050405020304" pitchFamily="18" charset="0"/>
+                <a:cs typeface="Times New Roman" panose="02020603050405020304" pitchFamily="18" charset="0"/>
+              </a:rPr>
+              <a:t>une boîte fixe : tu dois décider la taille à l'avance. Une Collection, c'est comme un sac à </a:t>
             </a:r>
             <a:r>
               <a:rPr lang="en-US" sz="1600" dirty="0" smtClean="0">
                 <a:latin typeface="Times New Roman" panose="02020603050405020304" pitchFamily="18" charset="0"/>
                 <a:cs typeface="Times New Roman" panose="02020603050405020304" pitchFamily="18" charset="0"/>
               </a:rPr>
-              <a:t xml:space="preserve"> </a:t>
-            </a:r>
-            <a:r>
-              <a:rPr lang="en-US" sz="1600" dirty="0">
+              <a:t>dos, </a:t>
+            </a:r>
+            <a:r>
+              <a:rPr lang="en-US" sz="1600" dirty="0" err="1" smtClean="0">
                 <a:latin typeface="Times New Roman" panose="02020603050405020304" pitchFamily="18" charset="0"/>
                 <a:cs typeface="Times New Roman" panose="02020603050405020304" pitchFamily="18" charset="0"/>
               </a:rPr>
-              <a:t xml:space="preserve">une boîte fixe : tu dois décider la taille à l'avance. Une Collection, c'est comme un sac à </a:t>
+              <a:t>tu</a:t>
             </a:r>
             <a:r>
               <a:rPr lang="en-US" sz="1600" dirty="0" smtClean="0">
                 <a:latin typeface="Times New Roman" panose="02020603050405020304" pitchFamily="18" charset="0"/>
                 <a:cs typeface="Times New Roman" panose="02020603050405020304" pitchFamily="18" charset="0"/>
               </a:rPr>
-              <a:t xml:space="preserve">dos, </a:t>
-            </a:r>
-            <a:r>
-              <a:rPr lang="en-US" sz="1600" dirty="0" err="1" smtClean="0">
-                <a:latin typeface="Times New Roman" panose="02020603050405020304" pitchFamily="18" charset="0"/>
-                <a:cs typeface="Times New Roman" panose="02020603050405020304" pitchFamily="18" charset="0"/>
-              </a:rPr>
-              <a:t>tu</a:t>
-            </a:r>
-            <a:r>
-              <a:rPr lang="en-US" sz="1600" dirty="0" smtClean="0">
-                <a:latin typeface="Times New Roman" panose="02020603050405020304" pitchFamily="18" charset="0"/>
-                <a:cs typeface="Times New Roman" panose="02020603050405020304" pitchFamily="18" charset="0"/>
-              </a:rPr>
-              <a:t xml:space="preserve"> </a:t>
+              <a:t> </a:t>
             </a:r>
             <a:r>
               <a:rPr lang="en-US" sz="1600" dirty="0">
@@ -36340,7 +36268,7 @@
                 <a:ea typeface="Consolas" pitchFamily="34" charset="-122"/>
                 <a:cs typeface="Times New Roman" panose="02020603050405020304" pitchFamily="18" charset="0"/>
               </a:rPr>
-              <a:t xml:space="preserve">etudiants.size();             </a:t>
+              <a:t>etudiants.size();             </a:t>
             </a:r>
             <a:endParaRPr lang="en-US" sz="900" dirty="0">
               <a:latin typeface="Times New Roman" panose="02020603050405020304" pitchFamily="18" charset="0"/>
@@ -36958,7 +36886,7 @@
                   <a:srgbClr val="FF0000"/>
                 </a:solidFill>
               </a:rPr>
-              <a:t xml:space="preserve">III.1. </a:t>
+              <a:t>III.1. </a:t>
             </a:r>
             <a:r>
               <a:rPr lang="fr-CA" sz="2400" cap="none" dirty="0" err="1" smtClean="0">
@@ -36974,7 +36902,7 @@
                   <a:srgbClr val="FF0000"/>
                 </a:solidFill>
               </a:rPr>
-              <a:t xml:space="preserve"> des collections</a:t>
+              <a:t> des collections</a:t>
             </a:r>
             <a:endParaRPr lang="fr-CA" sz="2400" cap="none" dirty="0">
               <a:solidFill>

</xml_diff>